<commit_message>
slides_media: digital twin slide fits the left half
Real data and the twin's knobs as two-across cards, the scenario deck as one
strip, so the diagram stays within 0.4-5.0 in and the right half is free.

Co-Authored-By: Claude Opus 5.5 <noreply@anthropic.com>
Claude-Session: https://claude.ai/code/session_017jr4N3mmHpSqRwkRYULYJk
</commit_message>
<xml_diff>
--- a/slides_media/digital_twin_slide.pptx
+++ b/slides_media/digital_twin_slide.pptx
@@ -502,7 +502,7 @@
           <a:p>
             <a:r>
               <a:rPr lang="en-US" dirty="0"/>
-              <a:t>Start from one real recorded pass: the scanned building, our real robots and sensor mounts, the trajectories they drove, and the Wi-Fi link we measured. The digital twin in Isaac Sim keeps all of that real and lets us change one thing at a time: the comms (latency, loss, bursts, bandwidth), sensor dropouts, where the poses come from (ground truth, noisy, or a SLAM algorithm's output), people and furniture, robot paths, and sensor models. Each setting is a scenario that comes with sensor data from every robot, ground-truth boxes for free, and the link per frame, so we can make as many training scenarios as we want. The models are then tested on a held-out real recording with its own measured link. Built today: comms, people and objects, robot paths, sensor models. Planned: sensor dropouts, SLAM as the pose source, and the training step itself.</a:t>
+              <a:t>Start from one real recorded pass: the scanned building, our real robots and sensor mounts, the trajectories they drove, and the Wi-Fi link we measured. The digital twin in Isaac Sim keeps all of that real and lets us change one thing at a time: the comms (latency, loss, bursts, bandwidth), sensor dropouts, where the poses come from (ground truth, noisy, or a SLAM algorithm's output), people and furniture, robot paths, and sensor models. Each setting is a scenario that comes with sensor data from every robot, ground-truth boxes for free, and the link per frame, so we can make as many training scenarios as we want. The models are then tested on a held-out real recording with its own measured link, so sim-trained and real-trained models can be compared on the same scene. Built today: comms, people and objects, robot paths, sensor models. Planned: sensor dropouts, SLAM as the pose source, and the training step itself.</a:t>
             </a:r>
             <a:endParaRPr lang="en-US" dirty="0"/>
           </a:p>
@@ -1036,12 +1036,12 @@
         </p:nvSpPr>
         <p:spPr>
           <a:xfrm>
-            <a:off x="585216" y="905256"/>
-            <a:ext cx="8183880" cy="731520"/>
+            <a:off x="576072" y="896112"/>
+            <a:ext cx="3977640" cy="896112"/>
           </a:xfrm>
           <a:prstGeom prst="roundRect">
             <a:avLst>
-              <a:gd name="adj" fmla="val 10000"/>
+              <a:gd name="adj" fmla="val 7143"/>
             </a:avLst>
           </a:prstGeom>
           <a:solidFill>
@@ -1064,11 +1064,11 @@
         <p:spPr>
           <a:xfrm>
             <a:off x="548640" y="868680"/>
-            <a:ext cx="8183880" cy="731520"/>
+            <a:ext cx="3977640" cy="896112"/>
           </a:xfrm>
           <a:prstGeom prst="roundRect">
             <a:avLst>
-              <a:gd name="adj" fmla="val 10000"/>
+              <a:gd name="adj" fmla="val 7143"/>
             </a:avLst>
           </a:prstGeom>
           <a:solidFill>
@@ -1090,8 +1090,8 @@
         </p:nvSpPr>
         <p:spPr>
           <a:xfrm>
-            <a:off x="685800" y="914400"/>
-            <a:ext cx="6400800" cy="256032"/>
+            <a:off x="658368" y="896112"/>
+            <a:ext cx="3758184" cy="237744"/>
           </a:xfrm>
           <a:prstGeom prst="rect">
             <a:avLst/>
@@ -1107,7 +1107,7 @@
               <a:buNone/>
             </a:pPr>
             <a:r>
-              <a:rPr lang="en-US" sz="1300" b="1" dirty="0">
+              <a:rPr lang="en-US" sz="1200" b="1" dirty="0">
                 <a:solidFill>
                   <a:srgbClr val="1B2430"/>
                 </a:solidFill>
@@ -1121,7 +1121,7 @@
               <a:buNone/>
             </a:pPr>
             <a:r>
-              <a:rPr lang="en-US" sz="1000" i="1" dirty="0">
+              <a:rPr lang="en-US" sz="900" i="1" dirty="0">
                 <a:solidFill>
                   <a:srgbClr val="5A6472"/>
                 </a:solidFill>
@@ -1129,9 +1129,9 @@
                 <a:ea typeface="Arial" pitchFamily="34" charset="-122"/>
                 <a:cs typeface="Arial" pitchFamily="34" charset="-120"/>
               </a:rPr>
-              <a:t>    one recorded pass</a:t>
-            </a:r>
-            <a:endParaRPr lang="en-US" sz="1300" dirty="0"/>
+              <a:t>   one recorded pass</a:t>
+            </a:r>
+            <a:endParaRPr lang="en-US" sz="1200" dirty="0"/>
           </a:p>
         </p:txBody>
       </p:sp>
@@ -1143,12 +1143,12 @@
         </p:nvSpPr>
         <p:spPr>
           <a:xfrm>
-            <a:off x="685800" y="1179576"/>
-            <a:ext cx="1908810" cy="347472"/>
+            <a:off x="658368" y="1143000"/>
+            <a:ext cx="1842516" cy="274320"/>
           </a:xfrm>
           <a:prstGeom prst="roundRect">
             <a:avLst>
-              <a:gd name="adj" fmla="val 13158"/>
+              <a:gd name="adj" fmla="val 13333"/>
             </a:avLst>
           </a:prstGeom>
           <a:solidFill>
@@ -1170,8 +1170,8 @@
         </p:nvSpPr>
         <p:spPr>
           <a:xfrm>
-            <a:off x="777240" y="1303020"/>
-            <a:ext cx="100584" cy="100584"/>
+            <a:off x="731520" y="1239012"/>
+            <a:ext cx="82296" cy="82296"/>
           </a:xfrm>
           <a:prstGeom prst="ellipse">
             <a:avLst/>
@@ -1179,7 +1179,7 @@
           <a:solidFill>
             <a:srgbClr val="C2571A"/>
           </a:solidFill>
-          <a:ln w="15875">
+          <a:ln w="13970">
             <a:solidFill>
               <a:srgbClr val="C2571A"/>
             </a:solidFill>
@@ -1195,8 +1195,8 @@
         </p:nvSpPr>
         <p:spPr>
           <a:xfrm>
-            <a:off x="941832" y="1197864"/>
-            <a:ext cx="1616202" cy="310896"/>
+            <a:off x="877824" y="1161288"/>
+            <a:ext cx="1595628" cy="237744"/>
           </a:xfrm>
           <a:prstGeom prst="rect">
             <a:avLst/>
@@ -1212,7 +1212,7 @@
               <a:buNone/>
             </a:pPr>
             <a:r>
-              <a:rPr lang="en-US" sz="1050" b="1" dirty="0">
+              <a:rPr lang="en-US" sz="950" b="1" dirty="0">
                 <a:solidFill>
                   <a:srgbClr val="1B2430"/>
                 </a:solidFill>
@@ -1222,14 +1222,14 @@
               </a:rPr>
               <a:t>Scanned building</a:t>
             </a:r>
-            <a:endParaRPr lang="en-US" sz="1050" dirty="0"/>
-          </a:p>
-          <a:p>
-            <a:pPr indent="0" marL="0">
-              <a:buNone/>
-            </a:pPr>
-            <a:r>
-              <a:rPr lang="en-US" sz="900" dirty="0">
+            <a:endParaRPr lang="en-US" sz="950" dirty="0"/>
+          </a:p>
+          <a:p>
+            <a:pPr indent="0" marL="0">
+              <a:buNone/>
+            </a:pPr>
+            <a:r>
+              <a:rPr lang="en-US" sz="800" dirty="0">
                 <a:solidFill>
                   <a:srgbClr val="5A6472"/>
                 </a:solidFill>
@@ -1239,7 +1239,7 @@
               </a:rPr>
               <a:t>reference map, cm-level</a:t>
             </a:r>
-            <a:endParaRPr lang="en-US" sz="1050" dirty="0"/>
+            <a:endParaRPr lang="en-US" sz="950" dirty="0"/>
           </a:p>
         </p:txBody>
       </p:sp>
@@ -1251,12 +1251,12 @@
         </p:nvSpPr>
         <p:spPr>
           <a:xfrm>
-            <a:off x="2686050" y="1179576"/>
-            <a:ext cx="1908810" cy="347472"/>
+            <a:off x="2574036" y="1143000"/>
+            <a:ext cx="1842516" cy="274320"/>
           </a:xfrm>
           <a:prstGeom prst="roundRect">
             <a:avLst>
-              <a:gd name="adj" fmla="val 13158"/>
+              <a:gd name="adj" fmla="val 13333"/>
             </a:avLst>
           </a:prstGeom>
           <a:solidFill>
@@ -1278,8 +1278,8 @@
         </p:nvSpPr>
         <p:spPr>
           <a:xfrm>
-            <a:off x="2777490" y="1303020"/>
-            <a:ext cx="100584" cy="100584"/>
+            <a:off x="2647188" y="1239012"/>
+            <a:ext cx="82296" cy="82296"/>
           </a:xfrm>
           <a:prstGeom prst="ellipse">
             <a:avLst/>
@@ -1287,7 +1287,7 @@
           <a:solidFill>
             <a:srgbClr val="C2571A"/>
           </a:solidFill>
-          <a:ln w="15875">
+          <a:ln w="13970">
             <a:solidFill>
               <a:srgbClr val="C2571A"/>
             </a:solidFill>
@@ -1303,8 +1303,8 @@
         </p:nvSpPr>
         <p:spPr>
           <a:xfrm>
-            <a:off x="2942082" y="1197864"/>
-            <a:ext cx="1616202" cy="310896"/>
+            <a:off x="2793492" y="1161288"/>
+            <a:ext cx="1595628" cy="237744"/>
           </a:xfrm>
           <a:prstGeom prst="rect">
             <a:avLst/>
@@ -1320,7 +1320,7 @@
               <a:buNone/>
             </a:pPr>
             <a:r>
-              <a:rPr lang="en-US" sz="1050" b="1" dirty="0">
+              <a:rPr lang="en-US" sz="950" b="1" dirty="0">
                 <a:solidFill>
                   <a:srgbClr val="1B2430"/>
                 </a:solidFill>
@@ -1330,14 +1330,14 @@
               </a:rPr>
               <a:t>Robots and sensors</a:t>
             </a:r>
-            <a:endParaRPr lang="en-US" sz="1050" dirty="0"/>
-          </a:p>
-          <a:p>
-            <a:pPr indent="0" marL="0">
-              <a:buNone/>
-            </a:pPr>
-            <a:r>
-              <a:rPr lang="en-US" sz="900" dirty="0">
+            <a:endParaRPr lang="en-US" sz="950" dirty="0"/>
+          </a:p>
+          <a:p>
+            <a:pPr indent="0" marL="0">
+              <a:buNone/>
+            </a:pPr>
+            <a:r>
+              <a:rPr lang="en-US" sz="800" dirty="0">
                 <a:solidFill>
                   <a:srgbClr val="5A6472"/>
                 </a:solidFill>
@@ -1347,7 +1347,7 @@
               </a:rPr>
               <a:t>real LiDARs, cameras, mounts</a:t>
             </a:r>
-            <a:endParaRPr lang="en-US" sz="1050" dirty="0"/>
+            <a:endParaRPr lang="en-US" sz="950" dirty="0"/>
           </a:p>
         </p:txBody>
       </p:sp>
@@ -1359,12 +1359,12 @@
         </p:nvSpPr>
         <p:spPr>
           <a:xfrm>
-            <a:off x="4686300" y="1179576"/>
-            <a:ext cx="1908810" cy="347472"/>
+            <a:off x="658368" y="1444752"/>
+            <a:ext cx="1842516" cy="274320"/>
           </a:xfrm>
           <a:prstGeom prst="roundRect">
             <a:avLst>
-              <a:gd name="adj" fmla="val 13158"/>
+              <a:gd name="adj" fmla="val 13333"/>
             </a:avLst>
           </a:prstGeom>
           <a:solidFill>
@@ -1386,8 +1386,8 @@
         </p:nvSpPr>
         <p:spPr>
           <a:xfrm>
-            <a:off x="4777740" y="1303020"/>
-            <a:ext cx="100584" cy="100584"/>
+            <a:off x="731520" y="1540764"/>
+            <a:ext cx="82296" cy="82296"/>
           </a:xfrm>
           <a:prstGeom prst="ellipse">
             <a:avLst/>
@@ -1395,7 +1395,7 @@
           <a:solidFill>
             <a:srgbClr val="C2571A"/>
           </a:solidFill>
-          <a:ln w="15875">
+          <a:ln w="13970">
             <a:solidFill>
               <a:srgbClr val="C2571A"/>
             </a:solidFill>
@@ -1411,8 +1411,8 @@
         </p:nvSpPr>
         <p:spPr>
           <a:xfrm>
-            <a:off x="4942332" y="1197864"/>
-            <a:ext cx="1616202" cy="310896"/>
+            <a:off x="877824" y="1463040"/>
+            <a:ext cx="1595628" cy="237744"/>
           </a:xfrm>
           <a:prstGeom prst="rect">
             <a:avLst/>
@@ -1428,7 +1428,7 @@
               <a:buNone/>
             </a:pPr>
             <a:r>
-              <a:rPr lang="en-US" sz="1050" b="1" dirty="0">
+              <a:rPr lang="en-US" sz="950" b="1" dirty="0">
                 <a:solidFill>
                   <a:srgbClr val="1B2430"/>
                 </a:solidFill>
@@ -1438,14 +1438,14 @@
               </a:rPr>
               <a:t>Real trajectories</a:t>
             </a:r>
-            <a:endParaRPr lang="en-US" sz="1050" dirty="0"/>
-          </a:p>
-          <a:p>
-            <a:pPr indent="0" marL="0">
-              <a:buNone/>
-            </a:pPr>
-            <a:r>
-              <a:rPr lang="en-US" sz="900" dirty="0">
+            <a:endParaRPr lang="en-US" sz="950" dirty="0"/>
+          </a:p>
+          <a:p>
+            <a:pPr indent="0" marL="0">
+              <a:buNone/>
+            </a:pPr>
+            <a:r>
+              <a:rPr lang="en-US" sz="800" dirty="0">
                 <a:solidFill>
                   <a:srgbClr val="5A6472"/>
                 </a:solidFill>
@@ -1455,7 +1455,7 @@
               </a:rPr>
               <a:t>where the robots drove</a:t>
             </a:r>
-            <a:endParaRPr lang="en-US" sz="1050" dirty="0"/>
+            <a:endParaRPr lang="en-US" sz="950" dirty="0"/>
           </a:p>
         </p:txBody>
       </p:sp>
@@ -1467,12 +1467,12 @@
         </p:nvSpPr>
         <p:spPr>
           <a:xfrm>
-            <a:off x="6686550" y="1179576"/>
-            <a:ext cx="1908810" cy="347472"/>
+            <a:off x="2574036" y="1444752"/>
+            <a:ext cx="1842516" cy="274320"/>
           </a:xfrm>
           <a:prstGeom prst="roundRect">
             <a:avLst>
-              <a:gd name="adj" fmla="val 13158"/>
+              <a:gd name="adj" fmla="val 13333"/>
             </a:avLst>
           </a:prstGeom>
           <a:solidFill>
@@ -1494,8 +1494,8 @@
         </p:nvSpPr>
         <p:spPr>
           <a:xfrm>
-            <a:off x="6777990" y="1303020"/>
-            <a:ext cx="100584" cy="100584"/>
+            <a:off x="2647188" y="1540764"/>
+            <a:ext cx="82296" cy="82296"/>
           </a:xfrm>
           <a:prstGeom prst="ellipse">
             <a:avLst/>
@@ -1503,7 +1503,7 @@
           <a:solidFill>
             <a:srgbClr val="C2571A"/>
           </a:solidFill>
-          <a:ln w="15875">
+          <a:ln w="13970">
             <a:solidFill>
               <a:srgbClr val="C2571A"/>
             </a:solidFill>
@@ -1519,8 +1519,8 @@
         </p:nvSpPr>
         <p:spPr>
           <a:xfrm>
-            <a:off x="6942582" y="1197864"/>
-            <a:ext cx="1616202" cy="310896"/>
+            <a:off x="2793492" y="1463040"/>
+            <a:ext cx="1595628" cy="237744"/>
           </a:xfrm>
           <a:prstGeom prst="rect">
             <a:avLst/>
@@ -1536,7 +1536,7 @@
               <a:buNone/>
             </a:pPr>
             <a:r>
-              <a:rPr lang="en-US" sz="1050" b="1" dirty="0">
+              <a:rPr lang="en-US" sz="950" b="1" dirty="0">
                 <a:solidFill>
                   <a:srgbClr val="1B2430"/>
                 </a:solidFill>
@@ -1546,14 +1546,14 @@
               </a:rPr>
               <a:t>Measured Wi-Fi link</a:t>
             </a:r>
-            <a:endParaRPr lang="en-US" sz="1050" dirty="0"/>
-          </a:p>
-          <a:p>
-            <a:pPr indent="0" marL="0">
-              <a:buNone/>
-            </a:pPr>
-            <a:r>
-              <a:rPr lang="en-US" sz="900" dirty="0">
+            <a:endParaRPr lang="en-US" sz="950" dirty="0"/>
+          </a:p>
+          <a:p>
+            <a:pPr indent="0" marL="0">
+              <a:buNone/>
+            </a:pPr>
+            <a:r>
+              <a:rPr lang="en-US" sz="800" dirty="0">
                 <a:solidFill>
                   <a:srgbClr val="5A6472"/>
                 </a:solidFill>
@@ -1563,7 +1563,7 @@
               </a:rPr>
               <a:t>RTT, goodput, outages</a:t>
             </a:r>
-            <a:endParaRPr lang="en-US" sz="1050" dirty="0"/>
+            <a:endParaRPr lang="en-US" sz="950" dirty="0"/>
           </a:p>
         </p:txBody>
       </p:sp>
@@ -1575,12 +1575,12 @@
         </p:nvSpPr>
         <p:spPr>
           <a:xfrm>
-            <a:off x="585216" y="1773936"/>
-            <a:ext cx="8183880" cy="1783080"/>
+            <a:off x="576072" y="1901952"/>
+            <a:ext cx="3977640" cy="1920240"/>
           </a:xfrm>
           <a:prstGeom prst="roundRect">
             <a:avLst>
-              <a:gd name="adj" fmla="val 4103"/>
+              <a:gd name="adj" fmla="val 3333"/>
             </a:avLst>
           </a:prstGeom>
           <a:solidFill>
@@ -1602,12 +1602,12 @@
         </p:nvSpPr>
         <p:spPr>
           <a:xfrm>
-            <a:off x="548640" y="1737360"/>
-            <a:ext cx="8183880" cy="1783080"/>
+            <a:off x="548640" y="1874520"/>
+            <a:ext cx="3977640" cy="1920240"/>
           </a:xfrm>
           <a:prstGeom prst="roundRect">
             <a:avLst>
-              <a:gd name="adj" fmla="val 4103"/>
+              <a:gd name="adj" fmla="val 3333"/>
             </a:avLst>
           </a:prstGeom>
           <a:solidFill>
@@ -1629,8 +1629,8 @@
         </p:nvSpPr>
         <p:spPr>
           <a:xfrm>
-            <a:off x="685800" y="1783080"/>
-            <a:ext cx="6400800" cy="256032"/>
+            <a:off x="658368" y="1901952"/>
+            <a:ext cx="2697480" cy="237744"/>
           </a:xfrm>
           <a:prstGeom prst="rect">
             <a:avLst/>
@@ -1646,7 +1646,7 @@
               <a:buNone/>
             </a:pPr>
             <a:r>
-              <a:rPr lang="en-US" sz="1300" b="1" dirty="0">
+              <a:rPr lang="en-US" sz="1200" b="1" dirty="0">
                 <a:solidFill>
                   <a:srgbClr val="1B2430"/>
                 </a:solidFill>
@@ -1656,21 +1656,7 @@
               </a:rPr>
               <a:t>2  Digital Twin · Isaac Sim</a:t>
             </a:r>
-            <a:pPr indent="0" marL="0">
-              <a:buNone/>
-            </a:pPr>
-            <a:r>
-              <a:rPr lang="en-US" sz="1000" i="1" dirty="0">
-                <a:solidFill>
-                  <a:srgbClr val="5A6472"/>
-                </a:solidFill>
-                <a:latin typeface="Arial" pitchFamily="34" charset="0"/>
-                <a:ea typeface="Arial" pitchFamily="34" charset="-122"/>
-                <a:cs typeface="Arial" pitchFamily="34" charset="-120"/>
-              </a:rPr>
-              <a:t>    change what you want, keep the rest real</a:t>
-            </a:r>
-            <a:endParaRPr lang="en-US" sz="1300" dirty="0"/>
+            <a:endParaRPr lang="en-US" sz="1200" dirty="0"/>
           </a:p>
         </p:txBody>
       </p:sp>
@@ -1682,12 +1668,12 @@
         </p:nvSpPr>
         <p:spPr>
           <a:xfrm>
-            <a:off x="685800" y="2084832"/>
-            <a:ext cx="1572768" cy="548640"/>
+            <a:off x="658368" y="2167128"/>
+            <a:ext cx="1842516" cy="292608"/>
           </a:xfrm>
           <a:prstGeom prst="roundRect">
             <a:avLst>
-              <a:gd name="adj" fmla="val 8333"/>
+              <a:gd name="adj" fmla="val 12500"/>
             </a:avLst>
           </a:prstGeom>
           <a:solidFill>
@@ -1709,8 +1695,8 @@
         </p:nvSpPr>
         <p:spPr>
           <a:xfrm>
-            <a:off x="777240" y="2194560"/>
-            <a:ext cx="100584" cy="100584"/>
+            <a:off x="731520" y="2272284"/>
+            <a:ext cx="82296" cy="82296"/>
           </a:xfrm>
           <a:prstGeom prst="ellipse">
             <a:avLst/>
@@ -1718,7 +1704,7 @@
           <a:solidFill>
             <a:srgbClr val="C2571A"/>
           </a:solidFill>
-          <a:ln w="15875">
+          <a:ln w="13970">
             <a:solidFill>
               <a:srgbClr val="C2571A"/>
             </a:solidFill>
@@ -1728,14 +1714,14 @@
       </p:sp>
       <p:sp>
         <p:nvSpPr>
-          <p:cNvPr id="27" name="knob title Comms"/>
+          <p:cNvPr id="27" name="knob text Comms"/>
           <p:cNvSpPr txBox="1"/>
           <p:nvPr/>
         </p:nvSpPr>
         <p:spPr>
           <a:xfrm>
-            <a:off x="932688" y="2130552"/>
-            <a:ext cx="1298448" cy="219456"/>
+            <a:off x="877824" y="2189988"/>
+            <a:ext cx="1595628" cy="246888"/>
           </a:xfrm>
           <a:prstGeom prst="rect">
             <a:avLst/>
@@ -1751,7 +1737,7 @@
               <a:buNone/>
             </a:pPr>
             <a:r>
-              <a:rPr lang="en-US" sz="1050" b="1" dirty="0">
+              <a:rPr lang="en-US" sz="950" b="1" dirty="0">
                 <a:solidFill>
                   <a:srgbClr val="1B2430"/>
                 </a:solidFill>
@@ -1761,20 +1747,89 @@
               </a:rPr>
               <a:t>Comms</a:t>
             </a:r>
-            <a:endParaRPr lang="en-US" sz="1050" dirty="0"/>
+            <a:endParaRPr lang="en-US" sz="950" dirty="0"/>
+          </a:p>
+          <a:p>
+            <a:pPr indent="0" marL="0">
+              <a:buNone/>
+            </a:pPr>
+            <a:r>
+              <a:rPr lang="en-US" sz="800" dirty="0">
+                <a:solidFill>
+                  <a:srgbClr val="5A6472"/>
+                </a:solidFill>
+                <a:latin typeface="Arial" pitchFamily="34" charset="0"/>
+                <a:ea typeface="Arial" pitchFamily="34" charset="-122"/>
+                <a:cs typeface="Arial" pitchFamily="34" charset="-120"/>
+              </a:rPr>
+              <a:t>latency · loss · bandwidth</a:t>
+            </a:r>
+            <a:endParaRPr lang="en-US" sz="950" dirty="0"/>
           </a:p>
         </p:txBody>
       </p:sp>
       <p:sp>
         <p:nvSpPr>
-          <p:cNvPr id="28" name="knob text Comms"/>
+          <p:cNvPr id="28" name="knob Sensor dropouts"/>
+          <p:cNvSpPr/>
+          <p:nvPr/>
+        </p:nvSpPr>
+        <p:spPr>
+          <a:xfrm>
+            <a:off x="2574036" y="2167128"/>
+            <a:ext cx="1842516" cy="292608"/>
+          </a:xfrm>
+          <a:prstGeom prst="roundRect">
+            <a:avLst>
+              <a:gd name="adj" fmla="val 12500"/>
+            </a:avLst>
+          </a:prstGeom>
+          <a:solidFill>
+            <a:srgbClr val="FFFFFF"/>
+          </a:solidFill>
+          <a:ln w="11430">
+            <a:solidFill>
+              <a:srgbClr val="E2C58E"/>
+            </a:solidFill>
+            <a:prstDash val="solid"/>
+          </a:ln>
+        </p:spPr>
+      </p:sp>
+      <p:sp>
+        <p:nvSpPr>
+          <p:cNvPr id="29" name="knob dot Sensor dropouts"/>
+          <p:cNvSpPr/>
+          <p:nvPr/>
+        </p:nvSpPr>
+        <p:spPr>
+          <a:xfrm>
+            <a:off x="2647188" y="2272284"/>
+            <a:ext cx="82296" cy="82296"/>
+          </a:xfrm>
+          <a:prstGeom prst="ellipse">
+            <a:avLst/>
+          </a:prstGeom>
+          <a:solidFill>
+            <a:srgbClr val="FFFFFF"/>
+          </a:solidFill>
+          <a:ln w="13970">
+            <a:solidFill>
+              <a:srgbClr val="C2571A"/>
+            </a:solidFill>
+            <a:prstDash val="solid"/>
+          </a:ln>
+        </p:spPr>
+      </p:sp>
+      <p:sp>
+        <p:nvSpPr>
+          <p:cNvPr id="30" name="knob text Sensor dropouts"/>
           <p:cNvSpPr txBox="1"/>
           <p:nvPr/>
         </p:nvSpPr>
         <p:spPr>
           <a:xfrm>
-            <a:off x="777240" y="2359152"/>
-            <a:ext cx="1435608" cy="237744"/>
+            <a:off x="2793492" y="2189988"/>
+            <a:ext cx="1595628" cy="246888"/>
           </a:xfrm>
           <a:prstGeom prst="rect">
             <a:avLst/>
@@ -1790,7 +1845,24 @@
               <a:buNone/>
             </a:pPr>
             <a:r>
-              <a:rPr lang="en-US" sz="900" dirty="0">
+              <a:rPr lang="en-US" sz="950" b="1" dirty="0">
+                <a:solidFill>
+                  <a:srgbClr val="1B2430"/>
+                </a:solidFill>
+                <a:latin typeface="Arial" pitchFamily="34" charset="0"/>
+                <a:ea typeface="Arial" pitchFamily="34" charset="-122"/>
+                <a:cs typeface="Arial" pitchFamily="34" charset="-120"/>
+              </a:rPr>
+              <a:t>Sensor dropouts</a:t>
+            </a:r>
+            <a:endParaRPr lang="en-US" sz="950" dirty="0"/>
+          </a:p>
+          <a:p>
+            <a:pPr indent="0" marL="0">
+              <a:buNone/>
+            </a:pPr>
+            <a:r>
+              <a:rPr lang="en-US" sz="800" dirty="0">
                 <a:solidFill>
                   <a:srgbClr val="5A6472"/>
                 </a:solidFill>
@@ -1798,26 +1870,26 @@
                 <a:ea typeface="Arial" pitchFamily="34" charset="-122"/>
                 <a:cs typeface="Arial" pitchFamily="34" charset="-120"/>
               </a:rPr>
-              <a:t>latency · loss · bandwidth</a:t>
-            </a:r>
-            <a:endParaRPr lang="en-US" sz="900" dirty="0"/>
+              <a:t>LiDAR or camera off</a:t>
+            </a:r>
+            <a:endParaRPr lang="en-US" sz="950" dirty="0"/>
           </a:p>
         </p:txBody>
       </p:sp>
       <p:sp>
         <p:nvSpPr>
-          <p:cNvPr id="29" name="knob Sensor dropouts"/>
-          <p:cNvSpPr/>
-          <p:nvPr/>
-        </p:nvSpPr>
-        <p:spPr>
-          <a:xfrm>
-            <a:off x="2331720" y="2084832"/>
-            <a:ext cx="1572768" cy="548640"/>
+          <p:cNvPr id="31" name="knob Pose source"/>
+          <p:cNvSpPr/>
+          <p:nvPr/>
+        </p:nvSpPr>
+        <p:spPr>
+          <a:xfrm>
+            <a:off x="658368" y="2496312"/>
+            <a:ext cx="1842516" cy="292608"/>
           </a:xfrm>
           <a:prstGeom prst="roundRect">
             <a:avLst>
-              <a:gd name="adj" fmla="val 8333"/>
+              <a:gd name="adj" fmla="val 12500"/>
             </a:avLst>
           </a:prstGeom>
           <a:solidFill>
@@ -1833,14 +1905,14 @@
       </p:sp>
       <p:sp>
         <p:nvSpPr>
-          <p:cNvPr id="30" name="knob dot Sensor dropouts"/>
-          <p:cNvSpPr/>
-          <p:nvPr/>
-        </p:nvSpPr>
-        <p:spPr>
-          <a:xfrm>
-            <a:off x="2423160" y="2194560"/>
-            <a:ext cx="100584" cy="100584"/>
+          <p:cNvPr id="32" name="knob dot Pose source"/>
+          <p:cNvSpPr/>
+          <p:nvPr/>
+        </p:nvSpPr>
+        <p:spPr>
+          <a:xfrm>
+            <a:off x="731520" y="2601468"/>
+            <a:ext cx="82296" cy="82296"/>
           </a:xfrm>
           <a:prstGeom prst="ellipse">
             <a:avLst/>
@@ -1848,7 +1920,7 @@
           <a:solidFill>
             <a:srgbClr val="FFFFFF"/>
           </a:solidFill>
-          <a:ln w="15875">
+          <a:ln w="13970">
             <a:solidFill>
               <a:srgbClr val="C2571A"/>
             </a:solidFill>
@@ -1858,14 +1930,14 @@
       </p:sp>
       <p:sp>
         <p:nvSpPr>
-          <p:cNvPr id="31" name="knob title Sensor dropouts"/>
+          <p:cNvPr id="33" name="knob text Pose source"/>
           <p:cNvSpPr txBox="1"/>
           <p:nvPr/>
         </p:nvSpPr>
         <p:spPr>
           <a:xfrm>
-            <a:off x="2578608" y="2130552"/>
-            <a:ext cx="1298448" cy="219456"/>
+            <a:off x="877824" y="2519172"/>
+            <a:ext cx="1595628" cy="246888"/>
           </a:xfrm>
           <a:prstGeom prst="rect">
             <a:avLst/>
@@ -1881,7 +1953,7 @@
               <a:buNone/>
             </a:pPr>
             <a:r>
-              <a:rPr lang="en-US" sz="1050" b="1" dirty="0">
+              <a:rPr lang="en-US" sz="950" b="1" dirty="0">
                 <a:solidFill>
                   <a:srgbClr val="1B2430"/>
                 </a:solidFill>
@@ -1889,22 +1961,91 @@
                 <a:ea typeface="Arial" pitchFamily="34" charset="-122"/>
                 <a:cs typeface="Arial" pitchFamily="34" charset="-120"/>
               </a:rPr>
-              <a:t>Sensor dropouts</a:t>
-            </a:r>
-            <a:endParaRPr lang="en-US" sz="1050" dirty="0"/>
+              <a:t>Pose source</a:t>
+            </a:r>
+            <a:endParaRPr lang="en-US" sz="950" dirty="0"/>
+          </a:p>
+          <a:p>
+            <a:pPr indent="0" marL="0">
+              <a:buNone/>
+            </a:pPr>
+            <a:r>
+              <a:rPr lang="en-US" sz="800" dirty="0">
+                <a:solidFill>
+                  <a:srgbClr val="5A6472"/>
+                </a:solidFill>
+                <a:latin typeface="Arial" pitchFamily="34" charset="0"/>
+                <a:ea typeface="Arial" pitchFamily="34" charset="-122"/>
+                <a:cs typeface="Arial" pitchFamily="34" charset="-120"/>
+              </a:rPr>
+              <a:t>ground truth · noisy · SLAM</a:t>
+            </a:r>
+            <a:endParaRPr lang="en-US" sz="950" dirty="0"/>
           </a:p>
         </p:txBody>
       </p:sp>
       <p:sp>
         <p:nvSpPr>
-          <p:cNvPr id="32" name="knob text Sensor dropouts"/>
+          <p:cNvPr id="34" name="knob People and objects"/>
+          <p:cNvSpPr/>
+          <p:nvPr/>
+        </p:nvSpPr>
+        <p:spPr>
+          <a:xfrm>
+            <a:off x="2574036" y="2496312"/>
+            <a:ext cx="1842516" cy="292608"/>
+          </a:xfrm>
+          <a:prstGeom prst="roundRect">
+            <a:avLst>
+              <a:gd name="adj" fmla="val 12500"/>
+            </a:avLst>
+          </a:prstGeom>
+          <a:solidFill>
+            <a:srgbClr val="FFFFFF"/>
+          </a:solidFill>
+          <a:ln w="11430">
+            <a:solidFill>
+              <a:srgbClr val="E2C58E"/>
+            </a:solidFill>
+            <a:prstDash val="solid"/>
+          </a:ln>
+        </p:spPr>
+      </p:sp>
+      <p:sp>
+        <p:nvSpPr>
+          <p:cNvPr id="35" name="knob dot People and objects"/>
+          <p:cNvSpPr/>
+          <p:nvPr/>
+        </p:nvSpPr>
+        <p:spPr>
+          <a:xfrm>
+            <a:off x="2647188" y="2601468"/>
+            <a:ext cx="82296" cy="82296"/>
+          </a:xfrm>
+          <a:prstGeom prst="ellipse">
+            <a:avLst/>
+          </a:prstGeom>
+          <a:solidFill>
+            <a:srgbClr val="C2571A"/>
+          </a:solidFill>
+          <a:ln w="13970">
+            <a:solidFill>
+              <a:srgbClr val="C2571A"/>
+            </a:solidFill>
+            <a:prstDash val="solid"/>
+          </a:ln>
+        </p:spPr>
+      </p:sp>
+      <p:sp>
+        <p:nvSpPr>
+          <p:cNvPr id="36" name="knob text People and objects"/>
           <p:cNvSpPr txBox="1"/>
           <p:nvPr/>
         </p:nvSpPr>
         <p:spPr>
           <a:xfrm>
-            <a:off x="2423160" y="2359152"/>
-            <a:ext cx="1435608" cy="237744"/>
+            <a:off x="2793492" y="2519172"/>
+            <a:ext cx="1595628" cy="246888"/>
           </a:xfrm>
           <a:prstGeom prst="rect">
             <a:avLst/>
@@ -1920,7 +2061,24 @@
               <a:buNone/>
             </a:pPr>
             <a:r>
-              <a:rPr lang="en-US" sz="900" dirty="0">
+              <a:rPr lang="en-US" sz="950" b="1" dirty="0">
+                <a:solidFill>
+                  <a:srgbClr val="1B2430"/>
+                </a:solidFill>
+                <a:latin typeface="Arial" pitchFamily="34" charset="0"/>
+                <a:ea typeface="Arial" pitchFamily="34" charset="-122"/>
+                <a:cs typeface="Arial" pitchFamily="34" charset="-120"/>
+              </a:rPr>
+              <a:t>People and objects</a:t>
+            </a:r>
+            <a:endParaRPr lang="en-US" sz="950" dirty="0"/>
+          </a:p>
+          <a:p>
+            <a:pPr indent="0" marL="0">
+              <a:buNone/>
+            </a:pPr>
+            <a:r>
+              <a:rPr lang="en-US" sz="800" dirty="0">
                 <a:solidFill>
                   <a:srgbClr val="5A6472"/>
                 </a:solidFill>
@@ -1928,26 +2086,26 @@
                 <a:ea typeface="Arial" pitchFamily="34" charset="-122"/>
                 <a:cs typeface="Arial" pitchFamily="34" charset="-120"/>
               </a:rPr>
-              <a:t>LiDAR or camera off</a:t>
-            </a:r>
-            <a:endParaRPr lang="en-US" sz="900" dirty="0"/>
+              <a:t>walkers · furniture</a:t>
+            </a:r>
+            <a:endParaRPr lang="en-US" sz="950" dirty="0"/>
           </a:p>
         </p:txBody>
       </p:sp>
       <p:sp>
         <p:nvSpPr>
-          <p:cNvPr id="33" name="knob Pose source"/>
-          <p:cNvSpPr/>
-          <p:nvPr/>
-        </p:nvSpPr>
-        <p:spPr>
-          <a:xfrm>
-            <a:off x="3977640" y="2084832"/>
-            <a:ext cx="1572768" cy="548640"/>
+          <p:cNvPr id="37" name="knob Robot paths"/>
+          <p:cNvSpPr/>
+          <p:nvPr/>
+        </p:nvSpPr>
+        <p:spPr>
+          <a:xfrm>
+            <a:off x="658368" y="2825496"/>
+            <a:ext cx="1842516" cy="292608"/>
           </a:xfrm>
           <a:prstGeom prst="roundRect">
             <a:avLst>
-              <a:gd name="adj" fmla="val 8333"/>
+              <a:gd name="adj" fmla="val 12500"/>
             </a:avLst>
           </a:prstGeom>
           <a:solidFill>
@@ -1963,22 +2121,22 @@
       </p:sp>
       <p:sp>
         <p:nvSpPr>
-          <p:cNvPr id="34" name="knob dot Pose source"/>
-          <p:cNvSpPr/>
-          <p:nvPr/>
-        </p:nvSpPr>
-        <p:spPr>
-          <a:xfrm>
-            <a:off x="4069080" y="2194560"/>
-            <a:ext cx="100584" cy="100584"/>
+          <p:cNvPr id="38" name="knob dot Robot paths"/>
+          <p:cNvSpPr/>
+          <p:nvPr/>
+        </p:nvSpPr>
+        <p:spPr>
+          <a:xfrm>
+            <a:off x="731520" y="2930652"/>
+            <a:ext cx="82296" cy="82296"/>
           </a:xfrm>
           <a:prstGeom prst="ellipse">
             <a:avLst/>
           </a:prstGeom>
           <a:solidFill>
-            <a:srgbClr val="FFFFFF"/>
-          </a:solidFill>
-          <a:ln w="15875">
+            <a:srgbClr val="C2571A"/>
+          </a:solidFill>
+          <a:ln w="13970">
             <a:solidFill>
               <a:srgbClr val="C2571A"/>
             </a:solidFill>
@@ -1988,14 +2146,14 @@
       </p:sp>
       <p:sp>
         <p:nvSpPr>
-          <p:cNvPr id="35" name="knob title Pose source"/>
+          <p:cNvPr id="39" name="knob text Robot paths"/>
           <p:cNvSpPr txBox="1"/>
           <p:nvPr/>
         </p:nvSpPr>
         <p:spPr>
           <a:xfrm>
-            <a:off x="4224528" y="2130552"/>
-            <a:ext cx="1298448" cy="219456"/>
+            <a:off x="877824" y="2848356"/>
+            <a:ext cx="1595628" cy="246888"/>
           </a:xfrm>
           <a:prstGeom prst="rect">
             <a:avLst/>
@@ -2011,7 +2169,7 @@
               <a:buNone/>
             </a:pPr>
             <a:r>
-              <a:rPr lang="en-US" sz="1050" b="1" dirty="0">
+              <a:rPr lang="en-US" sz="950" b="1" dirty="0">
                 <a:solidFill>
                   <a:srgbClr val="1B2430"/>
                 </a:solidFill>
@@ -2019,22 +2177,91 @@
                 <a:ea typeface="Arial" pitchFamily="34" charset="-122"/>
                 <a:cs typeface="Arial" pitchFamily="34" charset="-120"/>
               </a:rPr>
-              <a:t>Pose source</a:t>
-            </a:r>
-            <a:endParaRPr lang="en-US" sz="1050" dirty="0"/>
+              <a:t>Robot paths</a:t>
+            </a:r>
+            <a:endParaRPr lang="en-US" sz="950" dirty="0"/>
+          </a:p>
+          <a:p>
+            <a:pPr indent="0" marL="0">
+              <a:buNone/>
+            </a:pPr>
+            <a:r>
+              <a:rPr lang="en-US" sz="800" dirty="0">
+                <a:solidFill>
+                  <a:srgbClr val="5A6472"/>
+                </a:solidFill>
+                <a:latin typeface="Arial" pitchFamily="34" charset="0"/>
+                <a:ea typeface="Arial" pitchFamily="34" charset="-122"/>
+                <a:cs typeface="Arial" pitchFamily="34" charset="-120"/>
+              </a:rPr>
+              <a:t>new routes · speed</a:t>
+            </a:r>
+            <a:endParaRPr lang="en-US" sz="950" dirty="0"/>
           </a:p>
         </p:txBody>
       </p:sp>
       <p:sp>
         <p:nvSpPr>
-          <p:cNvPr id="36" name="knob text Pose source"/>
+          <p:cNvPr id="40" name="knob Sensor models"/>
+          <p:cNvSpPr/>
+          <p:nvPr/>
+        </p:nvSpPr>
+        <p:spPr>
+          <a:xfrm>
+            <a:off x="2574036" y="2825496"/>
+            <a:ext cx="1842516" cy="292608"/>
+          </a:xfrm>
+          <a:prstGeom prst="roundRect">
+            <a:avLst>
+              <a:gd name="adj" fmla="val 12500"/>
+            </a:avLst>
+          </a:prstGeom>
+          <a:solidFill>
+            <a:srgbClr val="FFFFFF"/>
+          </a:solidFill>
+          <a:ln w="11430">
+            <a:solidFill>
+              <a:srgbClr val="E2C58E"/>
+            </a:solidFill>
+            <a:prstDash val="solid"/>
+          </a:ln>
+        </p:spPr>
+      </p:sp>
+      <p:sp>
+        <p:nvSpPr>
+          <p:cNvPr id="41" name="knob dot Sensor models"/>
+          <p:cNvSpPr/>
+          <p:nvPr/>
+        </p:nvSpPr>
+        <p:spPr>
+          <a:xfrm>
+            <a:off x="2647188" y="2930652"/>
+            <a:ext cx="82296" cy="82296"/>
+          </a:xfrm>
+          <a:prstGeom prst="ellipse">
+            <a:avLst/>
+          </a:prstGeom>
+          <a:solidFill>
+            <a:srgbClr val="C2571A"/>
+          </a:solidFill>
+          <a:ln w="13970">
+            <a:solidFill>
+              <a:srgbClr val="C2571A"/>
+            </a:solidFill>
+            <a:prstDash val="solid"/>
+          </a:ln>
+        </p:spPr>
+      </p:sp>
+      <p:sp>
+        <p:nvSpPr>
+          <p:cNvPr id="42" name="knob text Sensor models"/>
           <p:cNvSpPr txBox="1"/>
           <p:nvPr/>
         </p:nvSpPr>
         <p:spPr>
           <a:xfrm>
-            <a:off x="4069080" y="2359152"/>
-            <a:ext cx="1435608" cy="237744"/>
+            <a:off x="2793492" y="2848356"/>
+            <a:ext cx="1595628" cy="246888"/>
           </a:xfrm>
           <a:prstGeom prst="rect">
             <a:avLst/>
@@ -2050,7 +2277,24 @@
               <a:buNone/>
             </a:pPr>
             <a:r>
-              <a:rPr lang="en-US" sz="900" dirty="0">
+              <a:rPr lang="en-US" sz="950" b="1" dirty="0">
+                <a:solidFill>
+                  <a:srgbClr val="1B2430"/>
+                </a:solidFill>
+                <a:latin typeface="Arial" pitchFamily="34" charset="0"/>
+                <a:ea typeface="Arial" pitchFamily="34" charset="-122"/>
+                <a:cs typeface="Arial" pitchFamily="34" charset="-120"/>
+              </a:rPr>
+              <a:t>Sensor models</a:t>
+            </a:r>
+            <a:endParaRPr lang="en-US" sz="950" dirty="0"/>
+          </a:p>
+          <a:p>
+            <a:pPr indent="0" marL="0">
+              <a:buNone/>
+            </a:pPr>
+            <a:r>
+              <a:rPr lang="en-US" sz="800" dirty="0">
                 <a:solidFill>
                   <a:srgbClr val="5A6472"/>
                 </a:solidFill>
@@ -2058,26 +2302,26 @@
                 <a:ea typeface="Arial" pitchFamily="34" charset="-122"/>
                 <a:cs typeface="Arial" pitchFamily="34" charset="-120"/>
               </a:rPr>
-              <a:t>ground truth · noisy · SLAM</a:t>
-            </a:r>
-            <a:endParaRPr lang="en-US" sz="900" dirty="0"/>
+              <a:t>LiDAR beams · resolution</a:t>
+            </a:r>
+            <a:endParaRPr lang="en-US" sz="950" dirty="0"/>
           </a:p>
         </p:txBody>
       </p:sp>
       <p:sp>
         <p:nvSpPr>
-          <p:cNvPr id="37" name="knob People and objects"/>
-          <p:cNvSpPr/>
-          <p:nvPr/>
-        </p:nvSpPr>
-        <p:spPr>
-          <a:xfrm>
-            <a:off x="685800" y="2706624"/>
-            <a:ext cx="1572768" cy="548640"/>
+          <p:cNvPr id="43" name="scenario card 3"/>
+          <p:cNvSpPr/>
+          <p:nvPr/>
+        </p:nvSpPr>
+        <p:spPr>
+          <a:xfrm>
+            <a:off x="731520" y="3264408"/>
+            <a:ext cx="3666744" cy="457200"/>
           </a:xfrm>
           <a:prstGeom prst="roundRect">
             <a:avLst>
-              <a:gd name="adj" fmla="val 8333"/>
+              <a:gd name="adj" fmla="val 8000"/>
             </a:avLst>
           </a:prstGeom>
           <a:solidFill>
@@ -2093,39 +2337,68 @@
       </p:sp>
       <p:sp>
         <p:nvSpPr>
-          <p:cNvPr id="38" name="knob dot People and objects"/>
-          <p:cNvSpPr/>
-          <p:nvPr/>
-        </p:nvSpPr>
-        <p:spPr>
-          <a:xfrm>
-            <a:off x="777240" y="2816352"/>
-            <a:ext cx="100584" cy="100584"/>
-          </a:xfrm>
-          <a:prstGeom prst="ellipse">
-            <a:avLst/>
-          </a:prstGeom>
-          <a:solidFill>
-            <a:srgbClr val="C2571A"/>
-          </a:solidFill>
-          <a:ln w="15875">
-            <a:solidFill>
-              <a:srgbClr val="C2571A"/>
-            </a:solidFill>
-            <a:prstDash val="solid"/>
-          </a:ln>
-        </p:spPr>
-      </p:sp>
-      <p:sp>
-        <p:nvSpPr>
-          <p:cNvPr id="39" name="knob title People and objects"/>
+          <p:cNvPr id="44" name="scenario card 2"/>
+          <p:cNvSpPr/>
+          <p:nvPr/>
+        </p:nvSpPr>
+        <p:spPr>
+          <a:xfrm>
+            <a:off x="694944" y="3227832"/>
+            <a:ext cx="3666744" cy="457200"/>
+          </a:xfrm>
+          <a:prstGeom prst="roundRect">
+            <a:avLst>
+              <a:gd name="adj" fmla="val 8000"/>
+            </a:avLst>
+          </a:prstGeom>
+          <a:solidFill>
+            <a:srgbClr val="FFFFFF"/>
+          </a:solidFill>
+          <a:ln w="11430">
+            <a:solidFill>
+              <a:srgbClr val="E2C58E"/>
+            </a:solidFill>
+            <a:prstDash val="solid"/>
+          </a:ln>
+        </p:spPr>
+      </p:sp>
+      <p:sp>
+        <p:nvSpPr>
+          <p:cNvPr id="45" name="scenario card 1"/>
+          <p:cNvSpPr/>
+          <p:nvPr/>
+        </p:nvSpPr>
+        <p:spPr>
+          <a:xfrm>
+            <a:off x="658368" y="3191256"/>
+            <a:ext cx="3666744" cy="457200"/>
+          </a:xfrm>
+          <a:prstGeom prst="roundRect">
+            <a:avLst>
+              <a:gd name="adj" fmla="val 8000"/>
+            </a:avLst>
+          </a:prstGeom>
+          <a:solidFill>
+            <a:srgbClr val="FFFFFF"/>
+          </a:solidFill>
+          <a:ln w="11430">
+            <a:solidFill>
+              <a:srgbClr val="E2C58E"/>
+            </a:solidFill>
+            <a:prstDash val="solid"/>
+          </a:ln>
+        </p:spPr>
+      </p:sp>
+      <p:sp>
+        <p:nvSpPr>
+          <p:cNvPr id="46" name="scenario text"/>
           <p:cNvSpPr txBox="1"/>
           <p:nvPr/>
         </p:nvSpPr>
         <p:spPr>
           <a:xfrm>
-            <a:off x="932688" y="2752344"/>
-            <a:ext cx="1298448" cy="219456"/>
+            <a:off x="749808" y="3227832"/>
+            <a:ext cx="3072384" cy="384048"/>
           </a:xfrm>
           <a:prstGeom prst="rect">
             <a:avLst/>
@@ -2141,7 +2414,7 @@
               <a:buNone/>
             </a:pPr>
             <a:r>
-              <a:rPr lang="en-US" sz="1050" b="1" dirty="0">
+              <a:rPr lang="en-US" sz="950" b="1" dirty="0">
                 <a:solidFill>
                   <a:srgbClr val="1B2430"/>
                 </a:solidFill>
@@ -2149,22 +2422,123 @@
                 <a:ea typeface="Arial" pitchFamily="34" charset="-122"/>
                 <a:cs typeface="Arial" pitchFamily="34" charset="-120"/>
               </a:rPr>
-              <a:t>People and objects</a:t>
-            </a:r>
-            <a:endParaRPr lang="en-US" sz="1050" dirty="0"/>
+              <a:t>Scenario 1</a:t>
+            </a:r>
+            <a:pPr indent="0" marL="0">
+              <a:buNone/>
+            </a:pPr>
+            <a:r>
+              <a:rPr lang="en-US" sz="800" dirty="0">
+                <a:solidFill>
+                  <a:srgbClr val="5A6472"/>
+                </a:solidFill>
+                <a:latin typeface="Arial" pitchFamily="34" charset="0"/>
+                <a:ea typeface="Arial" pitchFamily="34" charset="-122"/>
+                <a:cs typeface="Arial" pitchFamily="34" charset="-120"/>
+              </a:rPr>
+              <a:t>  4 people · 30% loss · camera off · SLAM poses</a:t>
+            </a:r>
+            <a:endParaRPr lang="en-US" sz="950" dirty="0"/>
+          </a:p>
+          <a:p>
+            <a:pPr indent="0" marL="0">
+              <a:buNone/>
+            </a:pPr>
+            <a:r>
+              <a:rPr lang="en-US" sz="850" b="1" dirty="0">
+                <a:solidFill>
+                  <a:srgbClr val="2E7D4F"/>
+                </a:solidFill>
+                <a:latin typeface="Arial" pitchFamily="34" charset="0"/>
+                <a:ea typeface="Arial" pitchFamily="34" charset="-122"/>
+                <a:cs typeface="Arial" pitchFamily="34" charset="-120"/>
+              </a:rPr>
+              <a:t>✓ </a:t>
+            </a:r>
+            <a:pPr indent="0" marL="0">
+              <a:buNone/>
+            </a:pPr>
+            <a:r>
+              <a:rPr lang="en-US" sz="850" dirty="0">
+                <a:solidFill>
+                  <a:srgbClr val="1B2430"/>
+                </a:solidFill>
+                <a:latin typeface="Arial" pitchFamily="34" charset="0"/>
+                <a:ea typeface="Arial" pitchFamily="34" charset="-122"/>
+                <a:cs typeface="Arial" pitchFamily="34" charset="-120"/>
+              </a:rPr>
+              <a:t>sensor data   </a:t>
+            </a:r>
+            <a:pPr indent="0" marL="0">
+              <a:buNone/>
+            </a:pPr>
+            <a:r>
+              <a:rPr lang="en-US" sz="850" b="1" dirty="0">
+                <a:solidFill>
+                  <a:srgbClr val="2E7D4F"/>
+                </a:solidFill>
+                <a:latin typeface="Arial" pitchFamily="34" charset="0"/>
+                <a:ea typeface="Arial" pitchFamily="34" charset="-122"/>
+                <a:cs typeface="Arial" pitchFamily="34" charset="-120"/>
+              </a:rPr>
+              <a:t>✓ </a:t>
+            </a:r>
+            <a:pPr indent="0" marL="0">
+              <a:buNone/>
+            </a:pPr>
+            <a:r>
+              <a:rPr lang="en-US" sz="850" dirty="0">
+                <a:solidFill>
+                  <a:srgbClr val="1B2430"/>
+                </a:solidFill>
+                <a:latin typeface="Arial" pitchFamily="34" charset="0"/>
+                <a:ea typeface="Arial" pitchFamily="34" charset="-122"/>
+                <a:cs typeface="Arial" pitchFamily="34" charset="-120"/>
+              </a:rPr>
+              <a:t>GT boxes   </a:t>
+            </a:r>
+            <a:pPr indent="0" marL="0">
+              <a:buNone/>
+            </a:pPr>
+            <a:r>
+              <a:rPr lang="en-US" sz="850" b="1" dirty="0">
+                <a:solidFill>
+                  <a:srgbClr val="2E7D4F"/>
+                </a:solidFill>
+                <a:latin typeface="Arial" pitchFamily="34" charset="0"/>
+                <a:ea typeface="Arial" pitchFamily="34" charset="-122"/>
+                <a:cs typeface="Arial" pitchFamily="34" charset="-120"/>
+              </a:rPr>
+              <a:t>✓ </a:t>
+            </a:r>
+            <a:pPr indent="0" marL="0">
+              <a:buNone/>
+            </a:pPr>
+            <a:r>
+              <a:rPr lang="en-US" sz="850" dirty="0">
+                <a:solidFill>
+                  <a:srgbClr val="1B2430"/>
+                </a:solidFill>
+                <a:latin typeface="Arial" pitchFamily="34" charset="0"/>
+                <a:ea typeface="Arial" pitchFamily="34" charset="-122"/>
+                <a:cs typeface="Arial" pitchFamily="34" charset="-120"/>
+              </a:rPr>
+              <a:t>link per frame</a:t>
+            </a:r>
+            <a:endParaRPr lang="en-US" sz="950" dirty="0"/>
           </a:p>
         </p:txBody>
       </p:sp>
       <p:sp>
         <p:nvSpPr>
-          <p:cNvPr id="40" name="knob text People and objects"/>
+          <p:cNvPr id="47" name="n scenarios"/>
           <p:cNvSpPr txBox="1"/>
           <p:nvPr/>
         </p:nvSpPr>
         <p:spPr>
           <a:xfrm>
-            <a:off x="777240" y="2980944"/>
-            <a:ext cx="1435608" cy="237744"/>
+            <a:off x="3822192" y="3191256"/>
+            <a:ext cx="438912" cy="457200"/>
           </a:xfrm>
           <a:prstGeom prst="rect">
             <a:avLst/>
@@ -2176,61 +2550,34 @@
           <a:bodyPr wrap="square" lIns="0" tIns="0" rIns="0" bIns="0" rtlCol="0" anchor="ctr"/>
           <a:lstStyle/>
           <a:p>
-            <a:pPr indent="0" marL="0">
-              <a:buNone/>
-            </a:pPr>
-            <a:r>
-              <a:rPr lang="en-US" sz="900" dirty="0">
-                <a:solidFill>
-                  <a:srgbClr val="5A6472"/>
-                </a:solidFill>
-                <a:latin typeface="Arial" pitchFamily="34" charset="0"/>
-                <a:ea typeface="Arial" pitchFamily="34" charset="-122"/>
-                <a:cs typeface="Arial" pitchFamily="34" charset="-120"/>
-              </a:rPr>
-              <a:t>walkers · furniture</a:t>
-            </a:r>
-            <a:endParaRPr lang="en-US" sz="900" dirty="0"/>
+            <a:pPr algn="r" indent="0" marL="0">
+              <a:buNone/>
+            </a:pPr>
+            <a:r>
+              <a:rPr lang="en-US" sz="1400" b="1" dirty="0">
+                <a:solidFill>
+                  <a:srgbClr val="C2571A"/>
+                </a:solidFill>
+                <a:latin typeface="Arial" pitchFamily="34" charset="0"/>
+                <a:ea typeface="Arial" pitchFamily="34" charset="-122"/>
+                <a:cs typeface="Arial" pitchFamily="34" charset="-120"/>
+              </a:rPr>
+              <a:t>× N</a:t>
+            </a:r>
+            <a:endParaRPr lang="en-US" sz="1400" dirty="0"/>
           </a:p>
         </p:txBody>
       </p:sp>
       <p:sp>
         <p:nvSpPr>
-          <p:cNvPr id="41" name="knob Robot paths"/>
-          <p:cNvSpPr/>
-          <p:nvPr/>
-        </p:nvSpPr>
-        <p:spPr>
-          <a:xfrm>
-            <a:off x="2331720" y="2706624"/>
-            <a:ext cx="1572768" cy="548640"/>
-          </a:xfrm>
-          <a:prstGeom prst="roundRect">
-            <a:avLst>
-              <a:gd name="adj" fmla="val 8333"/>
-            </a:avLst>
-          </a:prstGeom>
-          <a:solidFill>
-            <a:srgbClr val="FFFFFF"/>
-          </a:solidFill>
-          <a:ln w="11430">
-            <a:solidFill>
-              <a:srgbClr val="E2C58E"/>
-            </a:solidFill>
-            <a:prstDash val="solid"/>
-          </a:ln>
-        </p:spPr>
-      </p:sp>
-      <p:sp>
-        <p:nvSpPr>
-          <p:cNvPr id="42" name="knob dot Robot paths"/>
-          <p:cNvSpPr/>
-          <p:nvPr/>
-        </p:nvSpPr>
-        <p:spPr>
-          <a:xfrm>
-            <a:off x="2423160" y="2816352"/>
-            <a:ext cx="100584" cy="100584"/>
+          <p:cNvPr id="48" name="legend built dot"/>
+          <p:cNvSpPr/>
+          <p:nvPr/>
+        </p:nvSpPr>
+        <p:spPr>
+          <a:xfrm>
+            <a:off x="3447288" y="1979676"/>
+            <a:ext cx="82296" cy="82296"/>
           </a:xfrm>
           <a:prstGeom prst="ellipse">
             <a:avLst/>
@@ -2238,7 +2585,7 @@
           <a:solidFill>
             <a:srgbClr val="C2571A"/>
           </a:solidFill>
-          <a:ln w="15875">
+          <a:ln w="13970">
             <a:solidFill>
               <a:srgbClr val="C2571A"/>
             </a:solidFill>
@@ -2248,14 +2595,14 @@
       </p:sp>
       <p:sp>
         <p:nvSpPr>
-          <p:cNvPr id="43" name="knob title Robot paths"/>
+          <p:cNvPr id="49" name="legend built"/>
           <p:cNvSpPr txBox="1"/>
           <p:nvPr/>
         </p:nvSpPr>
         <p:spPr>
           <a:xfrm>
-            <a:off x="2578608" y="2752344"/>
-            <a:ext cx="1298448" cy="219456"/>
+            <a:off x="3557016" y="1929384"/>
+            <a:ext cx="320040" cy="182880"/>
           </a:xfrm>
           <a:prstGeom prst="rect">
             <a:avLst/>
@@ -2271,30 +2618,55 @@
               <a:buNone/>
             </a:pPr>
             <a:r>
-              <a:rPr lang="en-US" sz="1050" b="1" dirty="0">
-                <a:solidFill>
-                  <a:srgbClr val="1B2430"/>
-                </a:solidFill>
-                <a:latin typeface="Arial" pitchFamily="34" charset="0"/>
-                <a:ea typeface="Arial" pitchFamily="34" charset="-122"/>
-                <a:cs typeface="Arial" pitchFamily="34" charset="-120"/>
-              </a:rPr>
-              <a:t>Robot paths</a:t>
-            </a:r>
-            <a:endParaRPr lang="en-US" sz="1050" dirty="0"/>
+              <a:rPr lang="en-US" sz="800" dirty="0">
+                <a:solidFill>
+                  <a:srgbClr val="5A6472"/>
+                </a:solidFill>
+                <a:latin typeface="Arial" pitchFamily="34" charset="0"/>
+                <a:ea typeface="Arial" pitchFamily="34" charset="-122"/>
+                <a:cs typeface="Arial" pitchFamily="34" charset="-120"/>
+              </a:rPr>
+              <a:t>built</a:t>
+            </a:r>
+            <a:endParaRPr lang="en-US" sz="800" dirty="0"/>
           </a:p>
         </p:txBody>
       </p:sp>
       <p:sp>
         <p:nvSpPr>
-          <p:cNvPr id="44" name="knob text Robot paths"/>
+          <p:cNvPr id="50" name="legend planned dot"/>
+          <p:cNvSpPr/>
+          <p:nvPr/>
+        </p:nvSpPr>
+        <p:spPr>
+          <a:xfrm>
+            <a:off x="3886200" y="1979676"/>
+            <a:ext cx="82296" cy="82296"/>
+          </a:xfrm>
+          <a:prstGeom prst="ellipse">
+            <a:avLst/>
+          </a:prstGeom>
+          <a:solidFill>
+            <a:srgbClr val="FFFFFF"/>
+          </a:solidFill>
+          <a:ln w="13970">
+            <a:solidFill>
+              <a:srgbClr val="C2571A"/>
+            </a:solidFill>
+            <a:prstDash val="solid"/>
+          </a:ln>
+        </p:spPr>
+      </p:sp>
+      <p:sp>
+        <p:nvSpPr>
+          <p:cNvPr id="51" name="legend planned"/>
           <p:cNvSpPr txBox="1"/>
           <p:nvPr/>
         </p:nvSpPr>
         <p:spPr>
           <a:xfrm>
-            <a:off x="2423160" y="2980944"/>
-            <a:ext cx="1435608" cy="237744"/>
+            <a:off x="3995928" y="1929384"/>
+            <a:ext cx="457200" cy="182880"/>
           </a:xfrm>
           <a:prstGeom prst="rect">
             <a:avLst/>
@@ -2310,7 +2682,7 @@
               <a:buNone/>
             </a:pPr>
             <a:r>
-              <a:rPr lang="en-US" sz="900" dirty="0">
+              <a:rPr lang="en-US" sz="800" dirty="0">
                 <a:solidFill>
                   <a:srgbClr val="5A6472"/>
                 </a:solidFill>
@@ -2318,74 +2690,76 @@
                 <a:ea typeface="Arial" pitchFamily="34" charset="-122"/>
                 <a:cs typeface="Arial" pitchFamily="34" charset="-120"/>
               </a:rPr>
-              <a:t>new routes · speed</a:t>
-            </a:r>
-            <a:endParaRPr lang="en-US" sz="900" dirty="0"/>
+              <a:t>planned</a:t>
+            </a:r>
+            <a:endParaRPr lang="en-US" sz="800" dirty="0"/>
           </a:p>
         </p:txBody>
       </p:sp>
       <p:sp>
         <p:nvSpPr>
-          <p:cNvPr id="45" name="knob Sensor models"/>
-          <p:cNvSpPr/>
-          <p:nvPr/>
-        </p:nvSpPr>
-        <p:spPr>
-          <a:xfrm>
-            <a:off x="3977640" y="2706624"/>
-            <a:ext cx="1572768" cy="548640"/>
+          <p:cNvPr id="52" name="train shadow"/>
+          <p:cNvSpPr/>
+          <p:nvPr/>
+        </p:nvSpPr>
+        <p:spPr>
+          <a:xfrm>
+            <a:off x="576072" y="3931920"/>
+            <a:ext cx="3977640" cy="384048"/>
           </a:xfrm>
           <a:prstGeom prst="roundRect">
             <a:avLst>
-              <a:gd name="adj" fmla="val 8333"/>
+              <a:gd name="adj" fmla="val 16667"/>
             </a:avLst>
           </a:prstGeom>
           <a:solidFill>
-            <a:srgbClr val="FFFFFF"/>
-          </a:solidFill>
-          <a:ln w="11430">
-            <a:solidFill>
-              <a:srgbClr val="E2C58E"/>
-            </a:solidFill>
-            <a:prstDash val="solid"/>
-          </a:ln>
-        </p:spPr>
-      </p:sp>
-      <p:sp>
-        <p:nvSpPr>
-          <p:cNvPr id="46" name="knob dot Sensor models"/>
-          <p:cNvSpPr/>
-          <p:nvPr/>
-        </p:nvSpPr>
-        <p:spPr>
-          <a:xfrm>
-            <a:off x="4069080" y="2816352"/>
-            <a:ext cx="100584" cy="100584"/>
-          </a:xfrm>
-          <a:prstGeom prst="ellipse">
-            <a:avLst/>
-          </a:prstGeom>
-          <a:solidFill>
-            <a:srgbClr val="C2571A"/>
-          </a:solidFill>
-          <a:ln w="15875">
-            <a:solidFill>
-              <a:srgbClr val="C2571A"/>
-            </a:solidFill>
-            <a:prstDash val="solid"/>
-          </a:ln>
-        </p:spPr>
-      </p:sp>
-      <p:sp>
-        <p:nvSpPr>
-          <p:cNvPr id="47" name="knob title Sensor models"/>
+            <a:srgbClr val="CCDAEE"/>
+          </a:solidFill>
+          <a:ln w="12700">
+            <a:solidFill>
+              <a:srgbClr val="CCDAEE"/>
+            </a:solidFill>
+            <a:prstDash val="solid"/>
+          </a:ln>
+        </p:spPr>
+      </p:sp>
+      <p:sp>
+        <p:nvSpPr>
+          <p:cNvPr id="53" name="train"/>
+          <p:cNvSpPr/>
+          <p:nvPr/>
+        </p:nvSpPr>
+        <p:spPr>
+          <a:xfrm>
+            <a:off x="548640" y="3904488"/>
+            <a:ext cx="3977640" cy="384048"/>
+          </a:xfrm>
+          <a:prstGeom prst="roundRect">
+            <a:avLst>
+              <a:gd name="adj" fmla="val 16667"/>
+            </a:avLst>
+          </a:prstGeom>
+          <a:solidFill>
+            <a:srgbClr val="DDE8F6"/>
+          </a:solidFill>
+          <a:ln w="12700">
+            <a:solidFill>
+              <a:srgbClr val="9DB7DD"/>
+            </a:solidFill>
+            <a:prstDash val="solid"/>
+          </a:ln>
+        </p:spPr>
+      </p:sp>
+      <p:sp>
+        <p:nvSpPr>
+          <p:cNvPr id="54" name="train text"/>
           <p:cNvSpPr txBox="1"/>
           <p:nvPr/>
         </p:nvSpPr>
         <p:spPr>
           <a:xfrm>
-            <a:off x="4224528" y="2752344"/>
-            <a:ext cx="1298448" cy="219456"/>
+            <a:off x="658368" y="3904488"/>
+            <a:ext cx="3154680" cy="384048"/>
           </a:xfrm>
           <a:prstGeom prst="rect">
             <a:avLst/>
@@ -2401,7 +2775,7 @@
               <a:buNone/>
             </a:pPr>
             <a:r>
-              <a:rPr lang="en-US" sz="1050" b="1" dirty="0">
+              <a:rPr lang="en-US" sz="1200" b="1" dirty="0">
                 <a:solidFill>
                   <a:srgbClr val="1B2430"/>
                 </a:solidFill>
@@ -2409,22 +2783,36 @@
                 <a:ea typeface="Arial" pitchFamily="34" charset="-122"/>
                 <a:cs typeface="Arial" pitchFamily="34" charset="-120"/>
               </a:rPr>
-              <a:t>Sensor models</a:t>
-            </a:r>
-            <a:endParaRPr lang="en-US" sz="1050" dirty="0"/>
+              <a:t>3  Train</a:t>
+            </a:r>
+            <a:pPr indent="0" marL="0">
+              <a:buNone/>
+            </a:pPr>
+            <a:r>
+              <a:rPr lang="en-US" sz="950" dirty="0">
+                <a:solidFill>
+                  <a:srgbClr val="1B2430"/>
+                </a:solidFill>
+                <a:latin typeface="Arial" pitchFamily="34" charset="0"/>
+                <a:ea typeface="Arial" pitchFamily="34" charset="-122"/>
+                <a:cs typeface="Arial" pitchFamily="34" charset="-120"/>
+              </a:rPr>
+              <a:t>   on digital-twin scenarios</a:t>
+            </a:r>
+            <a:endParaRPr lang="en-US" sz="1200" dirty="0"/>
           </a:p>
         </p:txBody>
       </p:sp>
       <p:sp>
         <p:nvSpPr>
-          <p:cNvPr id="48" name="knob text Sensor models"/>
+          <p:cNvPr id="55" name="train status"/>
           <p:cNvSpPr txBox="1"/>
           <p:nvPr/>
         </p:nvSpPr>
         <p:spPr>
           <a:xfrm>
-            <a:off x="4069080" y="2980944"/>
-            <a:ext cx="1435608" cy="237744"/>
+            <a:off x="3749040" y="3904488"/>
+            <a:ext cx="667512" cy="384048"/>
           </a:xfrm>
           <a:prstGeom prst="rect">
             <a:avLst/>
@@ -2436,11 +2824,11 @@
           <a:bodyPr wrap="square" lIns="0" tIns="0" rIns="0" bIns="0" rtlCol="0" anchor="ctr"/>
           <a:lstStyle/>
           <a:p>
-            <a:pPr indent="0" marL="0">
-              <a:buNone/>
-            </a:pPr>
-            <a:r>
-              <a:rPr lang="en-US" sz="900" dirty="0">
+            <a:pPr algn="r" indent="0" marL="0">
+              <a:buNone/>
+            </a:pPr>
+            <a:r>
+              <a:rPr lang="en-US" sz="850" i="1" dirty="0">
                 <a:solidFill>
                   <a:srgbClr val="5A6472"/>
                 </a:solidFill>
@@ -2448,47 +2836,76 @@
                 <a:ea typeface="Arial" pitchFamily="34" charset="-122"/>
                 <a:cs typeface="Arial" pitchFamily="34" charset="-120"/>
               </a:rPr>
-              <a:t>LiDAR beams · resolution</a:t>
-            </a:r>
-            <a:endParaRPr lang="en-US" sz="900" dirty="0"/>
+              <a:t>next step</a:t>
+            </a:r>
+            <a:endParaRPr lang="en-US" sz="850" dirty="0"/>
           </a:p>
         </p:txBody>
       </p:sp>
       <p:sp>
         <p:nvSpPr>
-          <p:cNvPr id="49" name="legend built dot"/>
-          <p:cNvSpPr/>
-          <p:nvPr/>
-        </p:nvSpPr>
-        <p:spPr>
-          <a:xfrm>
-            <a:off x="704088" y="3291840"/>
-            <a:ext cx="100584" cy="100584"/>
-          </a:xfrm>
-          <a:prstGeom prst="ellipse">
-            <a:avLst/>
-          </a:prstGeom>
-          <a:solidFill>
-            <a:srgbClr val="C2571A"/>
-          </a:solidFill>
-          <a:ln w="15875">
-            <a:solidFill>
-              <a:srgbClr val="C2571A"/>
-            </a:solidFill>
-            <a:prstDash val="solid"/>
-          </a:ln>
-        </p:spPr>
-      </p:sp>
-      <p:sp>
-        <p:nvSpPr>
-          <p:cNvPr id="50" name="legend built"/>
+          <p:cNvPr id="56" name="test on real shadow"/>
+          <p:cNvSpPr/>
+          <p:nvPr/>
+        </p:nvSpPr>
+        <p:spPr>
+          <a:xfrm>
+            <a:off x="576072" y="4425696"/>
+            <a:ext cx="3977640" cy="384048"/>
+          </a:xfrm>
+          <a:prstGeom prst="roundRect">
+            <a:avLst>
+              <a:gd name="adj" fmla="val 16667"/>
+            </a:avLst>
+          </a:prstGeom>
+          <a:solidFill>
+            <a:srgbClr val="CDE5D3"/>
+          </a:solidFill>
+          <a:ln w="12700">
+            <a:solidFill>
+              <a:srgbClr val="CDE5D3"/>
+            </a:solidFill>
+            <a:prstDash val="solid"/>
+          </a:ln>
+        </p:spPr>
+      </p:sp>
+      <p:sp>
+        <p:nvSpPr>
+          <p:cNvPr id="57" name="test on real"/>
+          <p:cNvSpPr/>
+          <p:nvPr/>
+        </p:nvSpPr>
+        <p:spPr>
+          <a:xfrm>
+            <a:off x="548640" y="4398264"/>
+            <a:ext cx="3977640" cy="384048"/>
+          </a:xfrm>
+          <a:prstGeom prst="roundRect">
+            <a:avLst>
+              <a:gd name="adj" fmla="val 16667"/>
+            </a:avLst>
+          </a:prstGeom>
+          <a:solidFill>
+            <a:srgbClr val="DFF0E3"/>
+          </a:solidFill>
+          <a:ln w="12700">
+            <a:solidFill>
+              <a:srgbClr val="9CCBA8"/>
+            </a:solidFill>
+            <a:prstDash val="solid"/>
+          </a:ln>
+        </p:spPr>
+      </p:sp>
+      <p:sp>
+        <p:nvSpPr>
+          <p:cNvPr id="58" name="test text"/>
           <p:cNvSpPr txBox="1"/>
           <p:nvPr/>
         </p:nvSpPr>
         <p:spPr>
           <a:xfrm>
-            <a:off x="850392" y="3236976"/>
-            <a:ext cx="457200" cy="201168"/>
+            <a:off x="658368" y="4398264"/>
+            <a:ext cx="3758184" cy="384048"/>
           </a:xfrm>
           <a:prstGeom prst="rect">
             <a:avLst/>
@@ -2504,835 +2921,44 @@
               <a:buNone/>
             </a:pPr>
             <a:r>
-              <a:rPr lang="en-US" sz="900" dirty="0">
-                <a:solidFill>
-                  <a:srgbClr val="5A6472"/>
-                </a:solidFill>
-                <a:latin typeface="Arial" pitchFamily="34" charset="0"/>
-                <a:ea typeface="Arial" pitchFamily="34" charset="-122"/>
-                <a:cs typeface="Arial" pitchFamily="34" charset="-120"/>
-              </a:rPr>
-              <a:t>built</a:t>
-            </a:r>
-            <a:endParaRPr lang="en-US" sz="900" dirty="0"/>
+              <a:rPr lang="en-US" sz="1200" b="1" dirty="0">
+                <a:solidFill>
+                  <a:srgbClr val="1B2430"/>
+                </a:solidFill>
+                <a:latin typeface="Arial" pitchFamily="34" charset="0"/>
+                <a:ea typeface="Arial" pitchFamily="34" charset="-122"/>
+                <a:cs typeface="Arial" pitchFamily="34" charset="-120"/>
+              </a:rPr>
+              <a:t>4  Test on real</a:t>
+            </a:r>
+            <a:pPr indent="0" marL="0">
+              <a:buNone/>
+            </a:pPr>
+            <a:r>
+              <a:rPr lang="en-US" sz="950" dirty="0">
+                <a:solidFill>
+                  <a:srgbClr val="1B2430"/>
+                </a:solidFill>
+                <a:latin typeface="Arial" pitchFamily="34" charset="0"/>
+                <a:ea typeface="Arial" pitchFamily="34" charset="-122"/>
+                <a:cs typeface="Arial" pitchFamily="34" charset="-120"/>
+              </a:rPr>
+              <a:t>   held-out real recording</a:t>
+            </a:r>
+            <a:endParaRPr lang="en-US" sz="1200" dirty="0"/>
           </a:p>
         </p:txBody>
       </p:sp>
       <p:sp>
         <p:nvSpPr>
-          <p:cNvPr id="51" name="legend planned dot"/>
-          <p:cNvSpPr/>
-          <p:nvPr/>
-        </p:nvSpPr>
-        <p:spPr>
-          <a:xfrm>
-            <a:off x="1280160" y="3291840"/>
-            <a:ext cx="100584" cy="100584"/>
-          </a:xfrm>
-          <a:prstGeom prst="ellipse">
-            <a:avLst/>
-          </a:prstGeom>
-          <a:solidFill>
-            <a:srgbClr val="FFFFFF"/>
-          </a:solidFill>
-          <a:ln w="15875">
-            <a:solidFill>
-              <a:srgbClr val="C2571A"/>
-            </a:solidFill>
-            <a:prstDash val="solid"/>
-          </a:ln>
-        </p:spPr>
-      </p:sp>
-      <p:sp>
-        <p:nvSpPr>
-          <p:cNvPr id="52" name="legend planned"/>
-          <p:cNvSpPr txBox="1"/>
-          <p:nvPr/>
-        </p:nvSpPr>
-        <p:spPr>
-          <a:xfrm>
-            <a:off x="1426464" y="3236976"/>
-            <a:ext cx="731520" cy="201168"/>
-          </a:xfrm>
-          <a:prstGeom prst="rect">
-            <a:avLst/>
-          </a:prstGeom>
-          <a:noFill/>
-          <a:ln/>
-        </p:spPr>
-        <p:txBody>
-          <a:bodyPr wrap="square" lIns="0" tIns="0" rIns="0" bIns="0" rtlCol="0" anchor="ctr"/>
-          <a:lstStyle/>
-          <a:p>
-            <a:pPr indent="0" marL="0">
-              <a:buNone/>
-            </a:pPr>
-            <a:r>
-              <a:rPr lang="en-US" sz="900" dirty="0">
-                <a:solidFill>
-                  <a:srgbClr val="5A6472"/>
-                </a:solidFill>
-                <a:latin typeface="Arial" pitchFamily="34" charset="0"/>
-                <a:ea typeface="Arial" pitchFamily="34" charset="-122"/>
-                <a:cs typeface="Arial" pitchFamily="34" charset="-120"/>
-              </a:rPr>
-              <a:t>planned</a:t>
-            </a:r>
-            <a:endParaRPr lang="en-US" sz="900" dirty="0"/>
-          </a:p>
-        </p:txBody>
-      </p:sp>
-      <p:sp>
-        <p:nvSpPr>
-          <p:cNvPr id="53" name="scenario card 3"/>
-          <p:cNvSpPr/>
-          <p:nvPr/>
-        </p:nvSpPr>
-        <p:spPr>
-          <a:xfrm>
-            <a:off x="5824728" y="2194560"/>
-            <a:ext cx="2633472" cy="1078992"/>
-          </a:xfrm>
-          <a:prstGeom prst="roundRect">
-            <a:avLst>
-              <a:gd name="adj" fmla="val 4237"/>
-            </a:avLst>
-          </a:prstGeom>
-          <a:solidFill>
-            <a:srgbClr val="FFFFFF"/>
-          </a:solidFill>
-          <a:ln w="11430">
-            <a:solidFill>
-              <a:srgbClr val="E2C58E"/>
-            </a:solidFill>
-            <a:prstDash val="solid"/>
-          </a:ln>
-        </p:spPr>
-      </p:sp>
-      <p:sp>
-        <p:nvSpPr>
-          <p:cNvPr id="54" name="scenario card 2"/>
-          <p:cNvSpPr/>
-          <p:nvPr/>
-        </p:nvSpPr>
-        <p:spPr>
-          <a:xfrm>
-            <a:off x="5769864" y="2139696"/>
-            <a:ext cx="2633472" cy="1078992"/>
-          </a:xfrm>
-          <a:prstGeom prst="roundRect">
-            <a:avLst>
-              <a:gd name="adj" fmla="val 4237"/>
-            </a:avLst>
-          </a:prstGeom>
-          <a:solidFill>
-            <a:srgbClr val="FFFFFF"/>
-          </a:solidFill>
-          <a:ln w="11430">
-            <a:solidFill>
-              <a:srgbClr val="E2C58E"/>
-            </a:solidFill>
-            <a:prstDash val="solid"/>
-          </a:ln>
-        </p:spPr>
-      </p:sp>
-      <p:sp>
-        <p:nvSpPr>
-          <p:cNvPr id="55" name="scenario card 1"/>
-          <p:cNvSpPr/>
-          <p:nvPr/>
-        </p:nvSpPr>
-        <p:spPr>
-          <a:xfrm>
-            <a:off x="5715000" y="2084832"/>
-            <a:ext cx="2633472" cy="1078992"/>
-          </a:xfrm>
-          <a:prstGeom prst="roundRect">
-            <a:avLst>
-              <a:gd name="adj" fmla="val 4237"/>
-            </a:avLst>
-          </a:prstGeom>
-          <a:solidFill>
-            <a:srgbClr val="FFFFFF"/>
-          </a:solidFill>
-          <a:ln w="11430">
-            <a:solidFill>
-              <a:srgbClr val="E2C58E"/>
-            </a:solidFill>
-            <a:prstDash val="solid"/>
-          </a:ln>
-        </p:spPr>
-      </p:sp>
-      <p:sp>
-        <p:nvSpPr>
-          <p:cNvPr id="56" name="scenario title"/>
-          <p:cNvSpPr txBox="1"/>
-          <p:nvPr/>
-        </p:nvSpPr>
-        <p:spPr>
-          <a:xfrm>
-            <a:off x="5852160" y="2139696"/>
-            <a:ext cx="2377440" cy="384048"/>
-          </a:xfrm>
-          <a:prstGeom prst="rect">
-            <a:avLst/>
-          </a:prstGeom>
-          <a:noFill/>
-          <a:ln/>
-        </p:spPr>
-        <p:txBody>
-          <a:bodyPr wrap="square" lIns="0" tIns="0" rIns="0" bIns="0" rtlCol="0" anchor="t"/>
-          <a:lstStyle/>
-          <a:p>
-            <a:pPr indent="0" marL="0">
-              <a:buNone/>
-            </a:pPr>
-            <a:r>
-              <a:rPr lang="en-US" sz="1200" b="1" dirty="0">
-                <a:solidFill>
-                  <a:srgbClr val="1B2430"/>
-                </a:solidFill>
-                <a:latin typeface="Arial" pitchFamily="34" charset="0"/>
-                <a:ea typeface="Arial" pitchFamily="34" charset="-122"/>
-                <a:cs typeface="Arial" pitchFamily="34" charset="-120"/>
-              </a:rPr>
-              <a:t>Scenario 1</a:t>
-            </a:r>
-            <a:endParaRPr lang="en-US" sz="1200" dirty="0"/>
-          </a:p>
-          <a:p>
-            <a:pPr indent="0" marL="0">
-              <a:buNone/>
-            </a:pPr>
-            <a:r>
-              <a:rPr lang="en-US" sz="850" dirty="0">
-                <a:solidFill>
-                  <a:srgbClr val="5A6472"/>
-                </a:solidFill>
-                <a:latin typeface="Arial" pitchFamily="34" charset="0"/>
-                <a:ea typeface="Arial" pitchFamily="34" charset="-122"/>
-                <a:cs typeface="Arial" pitchFamily="34" charset="-120"/>
-              </a:rPr>
-              <a:t>4 people · 30% loss · camera off · SLAM poses</a:t>
-            </a:r>
-            <a:endParaRPr lang="en-US" sz="1200" dirty="0"/>
-          </a:p>
-        </p:txBody>
-      </p:sp>
-      <p:sp>
-        <p:nvSpPr>
-          <p:cNvPr id="57" name="scenario check 1"/>
-          <p:cNvSpPr txBox="1"/>
-          <p:nvPr/>
-        </p:nvSpPr>
-        <p:spPr>
-          <a:xfrm>
-            <a:off x="5852160" y="2560320"/>
-            <a:ext cx="2423160" cy="182880"/>
-          </a:xfrm>
-          <a:prstGeom prst="rect">
-            <a:avLst/>
-          </a:prstGeom>
-          <a:noFill/>
-          <a:ln/>
-        </p:spPr>
-        <p:txBody>
-          <a:bodyPr wrap="square" lIns="0" tIns="0" rIns="0" bIns="0" rtlCol="0" anchor="ctr"/>
-          <a:lstStyle/>
-          <a:p>
-            <a:pPr indent="0" marL="0">
-              <a:buNone/>
-            </a:pPr>
-            <a:r>
-              <a:rPr lang="en-US" sz="950" b="1" dirty="0">
-                <a:solidFill>
-                  <a:srgbClr val="2E7D4F"/>
-                </a:solidFill>
-                <a:latin typeface="Arial" pitchFamily="34" charset="0"/>
-                <a:ea typeface="Arial" pitchFamily="34" charset="-122"/>
-                <a:cs typeface="Arial" pitchFamily="34" charset="-120"/>
-              </a:rPr>
-              <a:t>✓  </a:t>
-            </a:r>
-            <a:pPr indent="0" marL="0">
-              <a:buNone/>
-            </a:pPr>
-            <a:r>
-              <a:rPr lang="en-US" sz="950" b="1" dirty="0">
-                <a:solidFill>
-                  <a:srgbClr val="1B2430"/>
-                </a:solidFill>
-                <a:latin typeface="Arial" pitchFamily="34" charset="0"/>
-                <a:ea typeface="Arial" pitchFamily="34" charset="-122"/>
-                <a:cs typeface="Arial" pitchFamily="34" charset="-120"/>
-              </a:rPr>
-              <a:t>LiDAR + camera data</a:t>
-            </a:r>
-            <a:pPr indent="0" marL="0">
-              <a:buNone/>
-            </a:pPr>
-            <a:r>
-              <a:rPr lang="en-US" sz="850" dirty="0">
-                <a:solidFill>
-                  <a:srgbClr val="5A6472"/>
-                </a:solidFill>
-                <a:latin typeface="Arial" pitchFamily="34" charset="0"/>
-                <a:ea typeface="Arial" pitchFamily="34" charset="-122"/>
-                <a:cs typeface="Arial" pitchFamily="34" charset="-120"/>
-              </a:rPr>
-              <a:t>   every robot</a:t>
-            </a:r>
-            <a:endParaRPr lang="en-US" sz="950" dirty="0"/>
-          </a:p>
-        </p:txBody>
-      </p:sp>
-      <p:sp>
-        <p:nvSpPr>
-          <p:cNvPr id="58" name="scenario check 2"/>
-          <p:cNvSpPr txBox="1"/>
-          <p:nvPr/>
-        </p:nvSpPr>
-        <p:spPr>
-          <a:xfrm>
-            <a:off x="5852160" y="2743200"/>
-            <a:ext cx="2423160" cy="182880"/>
-          </a:xfrm>
-          <a:prstGeom prst="rect">
-            <a:avLst/>
-          </a:prstGeom>
-          <a:noFill/>
-          <a:ln/>
-        </p:spPr>
-        <p:txBody>
-          <a:bodyPr wrap="square" lIns="0" tIns="0" rIns="0" bIns="0" rtlCol="0" anchor="ctr"/>
-          <a:lstStyle/>
-          <a:p>
-            <a:pPr indent="0" marL="0">
-              <a:buNone/>
-            </a:pPr>
-            <a:r>
-              <a:rPr lang="en-US" sz="950" b="1" dirty="0">
-                <a:solidFill>
-                  <a:srgbClr val="2E7D4F"/>
-                </a:solidFill>
-                <a:latin typeface="Arial" pitchFamily="34" charset="0"/>
-                <a:ea typeface="Arial" pitchFamily="34" charset="-122"/>
-                <a:cs typeface="Arial" pitchFamily="34" charset="-120"/>
-              </a:rPr>
-              <a:t>✓  </a:t>
-            </a:r>
-            <a:pPr indent="0" marL="0">
-              <a:buNone/>
-            </a:pPr>
-            <a:r>
-              <a:rPr lang="en-US" sz="950" b="1" dirty="0">
-                <a:solidFill>
-                  <a:srgbClr val="1B2430"/>
-                </a:solidFill>
-                <a:latin typeface="Arial" pitchFamily="34" charset="0"/>
-                <a:ea typeface="Arial" pitchFamily="34" charset="-122"/>
-                <a:cs typeface="Arial" pitchFamily="34" charset="-120"/>
-              </a:rPr>
-              <a:t>Ground-truth boxes</a:t>
-            </a:r>
-            <a:pPr indent="0" marL="0">
-              <a:buNone/>
-            </a:pPr>
-            <a:r>
-              <a:rPr lang="en-US" sz="850" dirty="0">
-                <a:solidFill>
-                  <a:srgbClr val="5A6472"/>
-                </a:solidFill>
-                <a:latin typeface="Arial" pitchFamily="34" charset="0"/>
-                <a:ea typeface="Arial" pitchFamily="34" charset="-122"/>
-                <a:cs typeface="Arial" pitchFamily="34" charset="-120"/>
-              </a:rPr>
-              <a:t>   every frame, free</a:t>
-            </a:r>
-            <a:endParaRPr lang="en-US" sz="950" dirty="0"/>
-          </a:p>
-        </p:txBody>
-      </p:sp>
-      <p:sp>
-        <p:nvSpPr>
-          <p:cNvPr id="59" name="scenario check 3"/>
-          <p:cNvSpPr txBox="1"/>
-          <p:nvPr/>
-        </p:nvSpPr>
-        <p:spPr>
-          <a:xfrm>
-            <a:off x="5852160" y="2926080"/>
-            <a:ext cx="2423160" cy="182880"/>
-          </a:xfrm>
-          <a:prstGeom prst="rect">
-            <a:avLst/>
-          </a:prstGeom>
-          <a:noFill/>
-          <a:ln/>
-        </p:spPr>
-        <p:txBody>
-          <a:bodyPr wrap="square" lIns="0" tIns="0" rIns="0" bIns="0" rtlCol="0" anchor="ctr"/>
-          <a:lstStyle/>
-          <a:p>
-            <a:pPr indent="0" marL="0">
-              <a:buNone/>
-            </a:pPr>
-            <a:r>
-              <a:rPr lang="en-US" sz="950" b="1" dirty="0">
-                <a:solidFill>
-                  <a:srgbClr val="2E7D4F"/>
-                </a:solidFill>
-                <a:latin typeface="Arial" pitchFamily="34" charset="0"/>
-                <a:ea typeface="Arial" pitchFamily="34" charset="-122"/>
-                <a:cs typeface="Arial" pitchFamily="34" charset="-120"/>
-              </a:rPr>
-              <a:t>✓  </a:t>
-            </a:r>
-            <a:pPr indent="0" marL="0">
-              <a:buNone/>
-            </a:pPr>
-            <a:r>
-              <a:rPr lang="en-US" sz="950" b="1" dirty="0">
-                <a:solidFill>
-                  <a:srgbClr val="1B2430"/>
-                </a:solidFill>
-                <a:latin typeface="Arial" pitchFamily="34" charset="0"/>
-                <a:ea typeface="Arial" pitchFamily="34" charset="-122"/>
-                <a:cs typeface="Arial" pitchFamily="34" charset="-120"/>
-              </a:rPr>
-              <a:t>Link per frame</a:t>
-            </a:r>
-            <a:pPr indent="0" marL="0">
-              <a:buNone/>
-            </a:pPr>
-            <a:r>
-              <a:rPr lang="en-US" sz="850" dirty="0">
-                <a:solidFill>
-                  <a:srgbClr val="5A6472"/>
-                </a:solidFill>
-                <a:latin typeface="Arial" pitchFamily="34" charset="0"/>
-                <a:ea typeface="Arial" pitchFamily="34" charset="-122"/>
-                <a:cs typeface="Arial" pitchFamily="34" charset="-120"/>
-              </a:rPr>
-              <a:t>   measured or tuned</a:t>
-            </a:r>
-            <a:endParaRPr lang="en-US" sz="950" dirty="0"/>
-          </a:p>
-        </p:txBody>
-      </p:sp>
-      <p:sp>
-        <p:nvSpPr>
-          <p:cNvPr id="60" name="n scenarios"/>
-          <p:cNvSpPr txBox="1"/>
-          <p:nvPr/>
-        </p:nvSpPr>
-        <p:spPr>
-          <a:xfrm>
-            <a:off x="6903720" y="3218688"/>
-            <a:ext cx="1691640" cy="237744"/>
-          </a:xfrm>
-          <a:prstGeom prst="rect">
-            <a:avLst/>
-          </a:prstGeom>
-          <a:noFill/>
-          <a:ln/>
-        </p:spPr>
-        <p:txBody>
-          <a:bodyPr wrap="square" lIns="0" tIns="0" rIns="0" bIns="0" rtlCol="0" anchor="ctr"/>
-          <a:lstStyle/>
-          <a:p>
-            <a:pPr algn="r" indent="0" marL="0">
-              <a:buNone/>
-            </a:pPr>
-            <a:r>
-              <a:rPr lang="en-US" sz="1300" b="1" dirty="0">
-                <a:solidFill>
-                  <a:srgbClr val="C2571A"/>
-                </a:solidFill>
-                <a:latin typeface="Arial" pitchFamily="34" charset="0"/>
-                <a:ea typeface="Arial" pitchFamily="34" charset="-122"/>
-                <a:cs typeface="Arial" pitchFamily="34" charset="-120"/>
-              </a:rPr>
-              <a:t>× N scenarios</a:t>
-            </a:r>
-            <a:endParaRPr lang="en-US" sz="1300" dirty="0"/>
-          </a:p>
-        </p:txBody>
-      </p:sp>
-      <p:sp>
-        <p:nvSpPr>
-          <p:cNvPr id="61" name="train shadow"/>
-          <p:cNvSpPr/>
-          <p:nvPr/>
-        </p:nvSpPr>
-        <p:spPr>
-          <a:xfrm>
-            <a:off x="585216" y="3694176"/>
-            <a:ext cx="8183880" cy="457200"/>
-          </a:xfrm>
-          <a:prstGeom prst="roundRect">
-            <a:avLst>
-              <a:gd name="adj" fmla="val 16000"/>
-            </a:avLst>
-          </a:prstGeom>
-          <a:solidFill>
-            <a:srgbClr val="CCDAEE"/>
-          </a:solidFill>
-          <a:ln w="12700">
-            <a:solidFill>
-              <a:srgbClr val="CCDAEE"/>
-            </a:solidFill>
-            <a:prstDash val="solid"/>
-          </a:ln>
-        </p:spPr>
-      </p:sp>
-      <p:sp>
-        <p:nvSpPr>
-          <p:cNvPr id="62" name="train"/>
-          <p:cNvSpPr/>
-          <p:nvPr/>
-        </p:nvSpPr>
-        <p:spPr>
-          <a:xfrm>
-            <a:off x="548640" y="3657600"/>
-            <a:ext cx="8183880" cy="457200"/>
-          </a:xfrm>
-          <a:prstGeom prst="roundRect">
-            <a:avLst>
-              <a:gd name="adj" fmla="val 16000"/>
-            </a:avLst>
-          </a:prstGeom>
-          <a:solidFill>
-            <a:srgbClr val="DDE8F6"/>
-          </a:solidFill>
-          <a:ln w="12700">
-            <a:solidFill>
-              <a:srgbClr val="9DB7DD"/>
-            </a:solidFill>
-            <a:prstDash val="solid"/>
-          </a:ln>
-        </p:spPr>
-      </p:sp>
-      <p:sp>
-        <p:nvSpPr>
-          <p:cNvPr id="63" name="train text"/>
-          <p:cNvSpPr txBox="1"/>
-          <p:nvPr/>
-        </p:nvSpPr>
-        <p:spPr>
-          <a:xfrm>
-            <a:off x="685800" y="3657600"/>
-            <a:ext cx="6995160" cy="457200"/>
-          </a:xfrm>
-          <a:prstGeom prst="rect">
-            <a:avLst/>
-          </a:prstGeom>
-          <a:noFill/>
-          <a:ln/>
-        </p:spPr>
-        <p:txBody>
-          <a:bodyPr wrap="square" lIns="0" tIns="0" rIns="0" bIns="0" rtlCol="0" anchor="ctr"/>
-          <a:lstStyle/>
-          <a:p>
-            <a:pPr indent="0" marL="0">
-              <a:buNone/>
-            </a:pPr>
-            <a:r>
-              <a:rPr lang="en-US" sz="1300" b="1" dirty="0">
-                <a:solidFill>
-                  <a:srgbClr val="1B2430"/>
-                </a:solidFill>
-                <a:latin typeface="Arial" pitchFamily="34" charset="0"/>
-                <a:ea typeface="Arial" pitchFamily="34" charset="-122"/>
-                <a:cs typeface="Arial" pitchFamily="34" charset="-120"/>
-              </a:rPr>
-              <a:t>3  Train</a:t>
-            </a:r>
-            <a:pPr indent="0" marL="0">
-              <a:buNone/>
-            </a:pPr>
-            <a:r>
-              <a:rPr lang="en-US" sz="1050" dirty="0">
-                <a:solidFill>
-                  <a:srgbClr val="1B2430"/>
-                </a:solidFill>
-                <a:latin typeface="Arial" pitchFamily="34" charset="0"/>
-                <a:ea typeface="Arial" pitchFamily="34" charset="-122"/>
-                <a:cs typeface="Arial" pitchFamily="34" charset="-120"/>
-              </a:rPr>
-              <a:t>      collaborative perception models on digital-twin scenarios built from real data</a:t>
-            </a:r>
-            <a:endParaRPr lang="en-US" sz="1300" dirty="0"/>
-          </a:p>
-        </p:txBody>
-      </p:sp>
-      <p:sp>
-        <p:nvSpPr>
-          <p:cNvPr id="64" name="train status"/>
-          <p:cNvSpPr txBox="1"/>
-          <p:nvPr/>
-        </p:nvSpPr>
-        <p:spPr>
-          <a:xfrm>
-            <a:off x="7680960" y="3657600"/>
-            <a:ext cx="914400" cy="457200"/>
-          </a:xfrm>
-          <a:prstGeom prst="rect">
-            <a:avLst/>
-          </a:prstGeom>
-          <a:noFill/>
-          <a:ln/>
-        </p:spPr>
-        <p:txBody>
-          <a:bodyPr wrap="square" lIns="0" tIns="0" rIns="0" bIns="0" rtlCol="0" anchor="ctr"/>
-          <a:lstStyle/>
-          <a:p>
-            <a:pPr algn="r" indent="0" marL="0">
-              <a:buNone/>
-            </a:pPr>
-            <a:r>
-              <a:rPr lang="en-US" sz="950" i="1" dirty="0">
-                <a:solidFill>
-                  <a:srgbClr val="5A6472"/>
-                </a:solidFill>
-                <a:latin typeface="Arial" pitchFamily="34" charset="0"/>
-                <a:ea typeface="Arial" pitchFamily="34" charset="-122"/>
-                <a:cs typeface="Arial" pitchFamily="34" charset="-120"/>
-              </a:rPr>
-              <a:t>next step</a:t>
-            </a:r>
-            <a:endParaRPr lang="en-US" sz="950" dirty="0"/>
-          </a:p>
-        </p:txBody>
-      </p:sp>
-      <p:sp>
-        <p:nvSpPr>
-          <p:cNvPr id="65" name="test on real shadow"/>
-          <p:cNvSpPr/>
-          <p:nvPr/>
-        </p:nvSpPr>
-        <p:spPr>
-          <a:xfrm>
-            <a:off x="585216" y="4288536"/>
-            <a:ext cx="8183880" cy="457200"/>
-          </a:xfrm>
-          <a:prstGeom prst="roundRect">
-            <a:avLst>
-              <a:gd name="adj" fmla="val 16000"/>
-            </a:avLst>
-          </a:prstGeom>
-          <a:solidFill>
-            <a:srgbClr val="CDE5D3"/>
-          </a:solidFill>
-          <a:ln w="12700">
-            <a:solidFill>
-              <a:srgbClr val="CDE5D3"/>
-            </a:solidFill>
-            <a:prstDash val="solid"/>
-          </a:ln>
-        </p:spPr>
-      </p:sp>
-      <p:sp>
-        <p:nvSpPr>
-          <p:cNvPr id="66" name="test on real"/>
-          <p:cNvSpPr/>
-          <p:nvPr/>
-        </p:nvSpPr>
-        <p:spPr>
-          <a:xfrm>
-            <a:off x="548640" y="4251960"/>
-            <a:ext cx="8183880" cy="457200"/>
-          </a:xfrm>
-          <a:prstGeom prst="roundRect">
-            <a:avLst>
-              <a:gd name="adj" fmla="val 16000"/>
-            </a:avLst>
-          </a:prstGeom>
-          <a:solidFill>
-            <a:srgbClr val="DFF0E3"/>
-          </a:solidFill>
-          <a:ln w="12700">
-            <a:solidFill>
-              <a:srgbClr val="9CCBA8"/>
-            </a:solidFill>
-            <a:prstDash val="solid"/>
-          </a:ln>
-        </p:spPr>
-      </p:sp>
-      <p:sp>
-        <p:nvSpPr>
-          <p:cNvPr id="67" name="test text"/>
-          <p:cNvSpPr txBox="1"/>
-          <p:nvPr/>
-        </p:nvSpPr>
-        <p:spPr>
-          <a:xfrm>
-            <a:off x="685800" y="4251960"/>
-            <a:ext cx="5440680" cy="457200"/>
-          </a:xfrm>
-          <a:prstGeom prst="rect">
-            <a:avLst/>
-          </a:prstGeom>
-          <a:noFill/>
-          <a:ln/>
-        </p:spPr>
-        <p:txBody>
-          <a:bodyPr wrap="square" lIns="0" tIns="0" rIns="0" bIns="0" rtlCol="0" anchor="ctr"/>
-          <a:lstStyle/>
-          <a:p>
-            <a:pPr indent="0" marL="0">
-              <a:buNone/>
-            </a:pPr>
-            <a:r>
-              <a:rPr lang="en-US" sz="1300" b="1" dirty="0">
-                <a:solidFill>
-                  <a:srgbClr val="1B2430"/>
-                </a:solidFill>
-                <a:latin typeface="Arial" pitchFamily="34" charset="0"/>
-                <a:ea typeface="Arial" pitchFamily="34" charset="-122"/>
-                <a:cs typeface="Arial" pitchFamily="34" charset="-120"/>
-              </a:rPr>
-              <a:t>4  Test on real</a:t>
-            </a:r>
-            <a:pPr indent="0" marL="0">
-              <a:buNone/>
-            </a:pPr>
-            <a:r>
-              <a:rPr lang="en-US" sz="1050" dirty="0">
-                <a:solidFill>
-                  <a:srgbClr val="1B2430"/>
-                </a:solidFill>
-                <a:latin typeface="Arial" pitchFamily="34" charset="0"/>
-                <a:ea typeface="Arial" pitchFamily="34" charset="-122"/>
-                <a:cs typeface="Arial" pitchFamily="34" charset="-120"/>
-              </a:rPr>
-              <a:t>      a held-out real recording with its measured link</a:t>
-            </a:r>
-            <a:endParaRPr lang="en-US" sz="1300" dirty="0"/>
-          </a:p>
-        </p:txBody>
-      </p:sp>
-      <p:sp>
-        <p:nvSpPr>
-          <p:cNvPr id="68" name="test note"/>
-          <p:cNvSpPr txBox="1"/>
-          <p:nvPr/>
-        </p:nvSpPr>
-        <p:spPr>
-          <a:xfrm>
-            <a:off x="6309360" y="4251960"/>
-            <a:ext cx="2286000" cy="457200"/>
-          </a:xfrm>
-          <a:prstGeom prst="rect">
-            <a:avLst/>
-          </a:prstGeom>
-          <a:noFill/>
-          <a:ln/>
-        </p:spPr>
-        <p:txBody>
-          <a:bodyPr wrap="square" lIns="0" tIns="0" rIns="0" bIns="0" rtlCol="0" anchor="ctr"/>
-          <a:lstStyle/>
-          <a:p>
-            <a:pPr algn="r" indent="0" marL="0">
-              <a:buNone/>
-            </a:pPr>
-            <a:r>
-              <a:rPr lang="en-US" sz="950" i="1" dirty="0">
-                <a:solidFill>
-                  <a:srgbClr val="5A6472"/>
-                </a:solidFill>
-                <a:latin typeface="Arial" pitchFamily="34" charset="0"/>
-                <a:ea typeface="Arial" pitchFamily="34" charset="-122"/>
-                <a:cs typeface="Arial" pitchFamily="34" charset="-120"/>
-              </a:rPr>
-              <a:t>sim-trained vs real-trained</a:t>
-            </a:r>
-            <a:endParaRPr lang="en-US" sz="950" dirty="0"/>
-          </a:p>
-        </p:txBody>
-      </p:sp>
-      <p:sp>
-        <p:nvSpPr>
-          <p:cNvPr id="69" name="arrow real to twin"/>
-          <p:cNvSpPr/>
-          <p:nvPr/>
-        </p:nvSpPr>
-        <p:spPr>
-          <a:xfrm>
-            <a:off x="4640580" y="1600200"/>
-            <a:ext cx="0" cy="137160"/>
-          </a:xfrm>
-          <a:prstGeom prst="line">
-            <a:avLst/>
-          </a:prstGeom>
-          <a:noFill/>
-          <a:ln w="19050">
-            <a:solidFill>
-              <a:srgbClr val="1B2430"/>
-            </a:solidFill>
-            <a:prstDash val="solid"/>
-            <a:tailEnd type="triangle"/>
-          </a:ln>
-        </p:spPr>
-      </p:sp>
-      <p:sp>
-        <p:nvSpPr>
-          <p:cNvPr id="70" name="arrow twin to train"/>
-          <p:cNvSpPr/>
-          <p:nvPr/>
-        </p:nvSpPr>
-        <p:spPr>
-          <a:xfrm>
-            <a:off x="4640580" y="3520440"/>
-            <a:ext cx="0" cy="137160"/>
-          </a:xfrm>
-          <a:prstGeom prst="line">
-            <a:avLst/>
-          </a:prstGeom>
-          <a:noFill/>
-          <a:ln w="19050">
-            <a:solidFill>
-              <a:srgbClr val="1B2430"/>
-            </a:solidFill>
-            <a:prstDash val="solid"/>
-            <a:tailEnd type="triangle"/>
-          </a:ln>
-        </p:spPr>
-      </p:sp>
-      <p:sp>
-        <p:nvSpPr>
-          <p:cNvPr id="71" name="arrow train to test"/>
-          <p:cNvSpPr/>
-          <p:nvPr/>
-        </p:nvSpPr>
-        <p:spPr>
-          <a:xfrm>
-            <a:off x="4640580" y="4114800"/>
-            <a:ext cx="0" cy="137160"/>
-          </a:xfrm>
-          <a:prstGeom prst="line">
-            <a:avLst/>
-          </a:prstGeom>
-          <a:noFill/>
-          <a:ln w="19050">
-            <a:solidFill>
-              <a:srgbClr val="1B2430"/>
-            </a:solidFill>
-            <a:prstDash val="solid"/>
-            <a:tailEnd type="triangle"/>
-          </a:ln>
-        </p:spPr>
-      </p:sp>
-      <p:sp>
-        <p:nvSpPr>
-          <p:cNvPr id="72" name="held-out top"/>
-          <p:cNvSpPr/>
-          <p:nvPr/>
-        </p:nvSpPr>
-        <p:spPr>
-          <a:xfrm>
-            <a:off x="384048" y="1234440"/>
-            <a:ext cx="164592" cy="0"/>
+          <p:cNvPr id="59" name="arrow real to twin"/>
+          <p:cNvSpPr/>
+          <p:nvPr/>
+        </p:nvSpPr>
+        <p:spPr>
+          <a:xfrm>
+            <a:off x="2537460" y="1764792"/>
+            <a:ext cx="0" cy="109728"/>
           </a:xfrm>
           <a:prstGeom prst="line">
             <a:avLst/>
@@ -3340,22 +2966,23 @@
           <a:noFill/>
           <a:ln w="15875">
             <a:solidFill>
-              <a:srgbClr val="5A6472"/>
-            </a:solidFill>
-            <a:prstDash val="dash"/>
-          </a:ln>
-        </p:spPr>
-      </p:sp>
-      <p:sp>
-        <p:nvSpPr>
-          <p:cNvPr id="73" name="held-out down"/>
-          <p:cNvSpPr/>
-          <p:nvPr/>
-        </p:nvSpPr>
-        <p:spPr>
-          <a:xfrm>
-            <a:off x="384048" y="1234440"/>
-            <a:ext cx="0" cy="3246120"/>
+              <a:srgbClr val="1B2430"/>
+            </a:solidFill>
+            <a:prstDash val="solid"/>
+            <a:tailEnd type="triangle"/>
+          </a:ln>
+        </p:spPr>
+      </p:sp>
+      <p:sp>
+        <p:nvSpPr>
+          <p:cNvPr id="60" name="arrow twin to train"/>
+          <p:cNvSpPr/>
+          <p:nvPr/>
+        </p:nvSpPr>
+        <p:spPr>
+          <a:xfrm>
+            <a:off x="2537460" y="3794760"/>
+            <a:ext cx="0" cy="109728"/>
           </a:xfrm>
           <a:prstGeom prst="line">
             <a:avLst/>
@@ -3363,22 +2990,23 @@
           <a:noFill/>
           <a:ln w="15875">
             <a:solidFill>
-              <a:srgbClr val="5A6472"/>
-            </a:solidFill>
-            <a:prstDash val="dash"/>
-          </a:ln>
-        </p:spPr>
-      </p:sp>
-      <p:sp>
-        <p:nvSpPr>
-          <p:cNvPr id="74" name="held-out in"/>
-          <p:cNvSpPr/>
-          <p:nvPr/>
-        </p:nvSpPr>
-        <p:spPr>
-          <a:xfrm>
-            <a:off x="384048" y="4480560"/>
-            <a:ext cx="164592" cy="0"/>
+              <a:srgbClr val="1B2430"/>
+            </a:solidFill>
+            <a:prstDash val="solid"/>
+            <a:tailEnd type="triangle"/>
+          </a:ln>
+        </p:spPr>
+      </p:sp>
+      <p:sp>
+        <p:nvSpPr>
+          <p:cNvPr id="61" name="arrow train to test"/>
+          <p:cNvSpPr/>
+          <p:nvPr/>
+        </p:nvSpPr>
+        <p:spPr>
+          <a:xfrm>
+            <a:off x="2537460" y="4288536"/>
+            <a:ext cx="0" cy="109728"/>
           </a:xfrm>
           <a:prstGeom prst="line">
             <a:avLst/>
@@ -3386,6 +3014,76 @@
           <a:noFill/>
           <a:ln w="15875">
             <a:solidFill>
+              <a:srgbClr val="1B2430"/>
+            </a:solidFill>
+            <a:prstDash val="solid"/>
+            <a:tailEnd type="triangle"/>
+          </a:ln>
+        </p:spPr>
+      </p:sp>
+      <p:sp>
+        <p:nvSpPr>
+          <p:cNvPr id="62" name="held-out top"/>
+          <p:cNvSpPr/>
+          <p:nvPr/>
+        </p:nvSpPr>
+        <p:spPr>
+          <a:xfrm>
+            <a:off x="384048" y="1280160"/>
+            <a:ext cx="164592" cy="0"/>
+          </a:xfrm>
+          <a:prstGeom prst="line">
+            <a:avLst/>
+          </a:prstGeom>
+          <a:noFill/>
+          <a:ln w="13970">
+            <a:solidFill>
+              <a:srgbClr val="5A6472"/>
+            </a:solidFill>
+            <a:prstDash val="dash"/>
+          </a:ln>
+        </p:spPr>
+      </p:sp>
+      <p:sp>
+        <p:nvSpPr>
+          <p:cNvPr id="63" name="held-out down"/>
+          <p:cNvSpPr/>
+          <p:nvPr/>
+        </p:nvSpPr>
+        <p:spPr>
+          <a:xfrm>
+            <a:off x="384048" y="1280160"/>
+            <a:ext cx="0" cy="3310128"/>
+          </a:xfrm>
+          <a:prstGeom prst="line">
+            <a:avLst/>
+          </a:prstGeom>
+          <a:noFill/>
+          <a:ln w="13970">
+            <a:solidFill>
+              <a:srgbClr val="5A6472"/>
+            </a:solidFill>
+            <a:prstDash val="dash"/>
+          </a:ln>
+        </p:spPr>
+      </p:sp>
+      <p:sp>
+        <p:nvSpPr>
+          <p:cNvPr id="64" name="held-out in"/>
+          <p:cNvSpPr/>
+          <p:nvPr/>
+        </p:nvSpPr>
+        <p:spPr>
+          <a:xfrm>
+            <a:off x="384048" y="4590288"/>
+            <a:ext cx="164592" cy="0"/>
+          </a:xfrm>
+          <a:prstGeom prst="line">
+            <a:avLst/>
+          </a:prstGeom>
+          <a:noFill/>
+          <a:ln w="13970">
+            <a:solidFill>
               <a:srgbClr val="5A6472"/>
             </a:solidFill>
             <a:prstDash val="dash"/>
@@ -3395,14 +3093,14 @@
       </p:sp>
       <p:sp>
         <p:nvSpPr>
-          <p:cNvPr id="75" name="held-out label"/>
+          <p:cNvPr id="65" name="held-out label"/>
           <p:cNvSpPr txBox="1"/>
           <p:nvPr/>
         </p:nvSpPr>
         <p:spPr>
           <a:xfrm>
-            <a:off x="109728" y="1828800"/>
-            <a:ext cx="219456" cy="2011680"/>
+            <a:off x="137160" y="1920240"/>
+            <a:ext cx="201168" cy="1828800"/>
           </a:xfrm>
           <a:prstGeom prst="rect">
             <a:avLst/>
@@ -3418,7 +3116,7 @@
               <a:buNone/>
             </a:pPr>
             <a:r>
-              <a:rPr lang="en-US" sz="900" i="1" dirty="0">
+              <a:rPr lang="en-US" sz="850" i="1" dirty="0">
                 <a:solidFill>
                   <a:srgbClr val="5A6472"/>
                 </a:solidFill>
@@ -3428,7 +3126,7 @@
               </a:rPr>
               <a:t>held-out real recording</a:t>
             </a:r>
-            <a:endParaRPr lang="en-US" sz="900" dirty="0"/>
+            <a:endParaRPr lang="en-US" sz="850" dirty="0"/>
           </a:p>
         </p:txBody>
       </p:sp>

</xml_diff>